<commit_message>
Fix three_cards rendering + regenerate Day 2 & Day 3
Generator fix: three_cards now renders card.title and card.body
(was only rendering card.label). Title in bold white, body in muted gray.

Day 3: fixed 4 empty content slides, regenerated. 104 slides, 2 minimal (both statements).
Day 2: regenerated with all fixes. 109 slides, 24 minimal (all section dividers/statements).
Both ZIPs cleaned.
</commit_message>
<xml_diff>
--- a/slides/Day2_Claude_Code_Fundamentals.pptx
+++ b/slides/Day2_Claude_Code_Fundamentals.pptx
@@ -18687,12 +18687,15 @@
           <a:lstStyle/>
           <a:p>
             <a:pPr algn="ctr">
-              <a:defRPr sz="2000" b="1">
-                <a:solidFill>
-                  <a:srgbClr val="FFFFFF"/>
-                </a:solidFill>
-              </a:defRPr>
-            </a:pPr>
+              <a:defRPr sz="1800" b="1">
+                <a:solidFill>
+                  <a:srgbClr val="FFFFFF"/>
+                </a:solidFill>
+              </a:defRPr>
+            </a:pPr>
+            <a:r>
+              <a:t>PostgreSQL</a:t>
+            </a:r>
           </a:p>
         </p:txBody>
       </p:sp>
@@ -18842,12 +18845,15 @@
           <a:lstStyle/>
           <a:p>
             <a:pPr algn="ctr">
-              <a:defRPr sz="2000" b="1">
-                <a:solidFill>
-                  <a:srgbClr val="FFFFFF"/>
-                </a:solidFill>
-              </a:defRPr>
-            </a:pPr>
+              <a:defRPr sz="1800" b="1">
+                <a:solidFill>
+                  <a:srgbClr val="FFFFFF"/>
+                </a:solidFill>
+              </a:defRPr>
+            </a:pPr>
+            <a:r>
+              <a:t>MySQL</a:t>
+            </a:r>
           </a:p>
         </p:txBody>
       </p:sp>
@@ -18997,12 +19003,15 @@
           <a:lstStyle/>
           <a:p>
             <a:pPr algn="ctr">
-              <a:defRPr sz="2000" b="1">
-                <a:solidFill>
-                  <a:srgbClr val="FFFFFF"/>
-                </a:solidFill>
-              </a:defRPr>
-            </a:pPr>
+              <a:defRPr sz="1800" b="1">
+                <a:solidFill>
+                  <a:srgbClr val="FFFFFF"/>
+                </a:solidFill>
+              </a:defRPr>
+            </a:pPr>
+            <a:r>
+              <a:t>SQLite</a:t>
+            </a:r>
           </a:p>
         </p:txBody>
       </p:sp>
@@ -34464,12 +34473,15 @@
           <a:lstStyle/>
           <a:p>
             <a:pPr algn="ctr">
-              <a:defRPr sz="2000" b="1">
-                <a:solidFill>
-                  <a:srgbClr val="FFFFFF"/>
-                </a:solidFill>
-              </a:defRPr>
-            </a:pPr>
+              <a:defRPr sz="1800" b="1">
+                <a:solidFill>
+                  <a:srgbClr val="FFFFFF"/>
+                </a:solidFill>
+              </a:defRPr>
+            </a:pPr>
+            <a:r>
+              <a:t>Suggest Only</a:t>
+            </a:r>
           </a:p>
         </p:txBody>
       </p:sp>
@@ -34619,12 +34631,15 @@
           <a:lstStyle/>
           <a:p>
             <a:pPr algn="ctr">
-              <a:defRPr sz="2000" b="1">
-                <a:solidFill>
-                  <a:srgbClr val="FFFFFF"/>
-                </a:solidFill>
-              </a:defRPr>
-            </a:pPr>
+              <a:defRPr sz="1800" b="1">
+                <a:solidFill>
+                  <a:srgbClr val="FFFFFF"/>
+                </a:solidFill>
+              </a:defRPr>
+            </a:pPr>
+            <a:r>
+              <a:t>Auto-Approve Read</a:t>
+            </a:r>
           </a:p>
         </p:txBody>
       </p:sp>
@@ -34774,12 +34789,15 @@
           <a:lstStyle/>
           <a:p>
             <a:pPr algn="ctr">
-              <a:defRPr sz="2000" b="1">
-                <a:solidFill>
-                  <a:srgbClr val="FFFFFF"/>
-                </a:solidFill>
-              </a:defRPr>
-            </a:pPr>
+              <a:defRPr sz="1800" b="1">
+                <a:solidFill>
+                  <a:srgbClr val="FFFFFF"/>
+                </a:solidFill>
+              </a:defRPr>
+            </a:pPr>
+            <a:r>
+              <a:t>Auto-Approve All</a:t>
+            </a:r>
           </a:p>
         </p:txBody>
       </p:sp>

</xml_diff>

<commit_message>
fix: wrap=square on all long text, fix remaining literal newlines
</commit_message>
<xml_diff>
--- a/slides/Day2_Claude_Code_Fundamentals.pptx
+++ b/slides/Day2_Claude_Code_Fundamentals.pptx
@@ -26545,7 +26545,7 @@
           <a:noFill/>
         </p:spPr>
         <p:txBody>
-          <a:bodyPr wrap="none">
+          <a:bodyPr wrap="square">
             <a:spAutoFit/>
           </a:bodyPr>
           <a:lstStyle/>
@@ -32563,7 +32563,7 @@
           <a:noFill/>
         </p:spPr>
         <p:txBody>
-          <a:bodyPr wrap="none">
+          <a:bodyPr wrap="square">
             <a:spAutoFit/>
           </a:bodyPr>
           <a:lstStyle/>
@@ -33859,7 +33859,49 @@
               </a:defRPr>
             </a:pPr>
             <a:r>
-              <a:t>CLAUDE.md is a configuration file that lives in your project root.\n\nClaude Code reads it first, every session.\n\nIt's your project's instruction manual for AI.</a:t>
+              <a:t>CLAUDE.md is a configuration file that lives in your project root.</a:t>
+            </a:r>
+          </a:p>
+          <a:p>
+            <a:pPr>
+              <a:defRPr sz="2400">
+                <a:solidFill>
+                  <a:srgbClr val="8B95A5"/>
+                </a:solidFill>
+              </a:defRPr>
+            </a:pPr>
+          </a:p>
+          <a:p>
+            <a:pPr>
+              <a:defRPr sz="2400">
+                <a:solidFill>
+                  <a:srgbClr val="8B95A5"/>
+                </a:solidFill>
+              </a:defRPr>
+            </a:pPr>
+            <a:r>
+              <a:t>Claude Code reads it first, every session.</a:t>
+            </a:r>
+          </a:p>
+          <a:p>
+            <a:pPr>
+              <a:defRPr sz="2400">
+                <a:solidFill>
+                  <a:srgbClr val="8B95A5"/>
+                </a:solidFill>
+              </a:defRPr>
+            </a:pPr>
+          </a:p>
+          <a:p>
+            <a:pPr>
+              <a:defRPr sz="2400">
+                <a:solidFill>
+                  <a:srgbClr val="8B95A5"/>
+                </a:solidFill>
+              </a:defRPr>
+            </a:pPr>
+            <a:r>
+              <a:t>It's your project's instruction manual for AI.</a:t>
             </a:r>
           </a:p>
         </p:txBody>
@@ -35037,7 +35079,7 @@
           <a:noFill/>
         </p:spPr>
         <p:txBody>
-          <a:bodyPr wrap="none">
+          <a:bodyPr wrap="square">
             <a:spAutoFit/>
           </a:bodyPr>
           <a:lstStyle/>
@@ -36011,7 +36053,7 @@
           <a:noFill/>
         </p:spPr>
         <p:txBody>
-          <a:bodyPr wrap="none">
+          <a:bodyPr wrap="square">
             <a:spAutoFit/>
           </a:bodyPr>
           <a:lstStyle/>
@@ -37062,7 +37104,7 @@
           <a:noFill/>
         </p:spPr>
         <p:txBody>
-          <a:bodyPr wrap="none">
+          <a:bodyPr wrap="square">
             <a:spAutoFit/>
           </a:bodyPr>
           <a:lstStyle/>
@@ -37279,7 +37321,7 @@
           <a:noFill/>
         </p:spPr>
         <p:txBody>
-          <a:bodyPr wrap="none">
+          <a:bodyPr wrap="square">
             <a:spAutoFit/>
           </a:bodyPr>
           <a:lstStyle/>
@@ -37918,7 +37960,7 @@
           <a:noFill/>
         </p:spPr>
         <p:txBody>
-          <a:bodyPr wrap="none">
+          <a:bodyPr wrap="square">
             <a:spAutoFit/>
           </a:bodyPr>
           <a:lstStyle/>
@@ -38232,7 +38274,7 @@
           <a:noFill/>
         </p:spPr>
         <p:txBody>
-          <a:bodyPr wrap="none">
+          <a:bodyPr wrap="square">
             <a:spAutoFit/>
           </a:bodyPr>
           <a:lstStyle/>
@@ -38587,7 +38629,7 @@
           <a:noFill/>
         </p:spPr>
         <p:txBody>
-          <a:bodyPr wrap="none">
+          <a:bodyPr wrap="square">
             <a:spAutoFit/>
           </a:bodyPr>
           <a:lstStyle/>
@@ -41779,7 +41821,7 @@
           <a:noFill/>
         </p:spPr>
         <p:txBody>
-          <a:bodyPr wrap="none">
+          <a:bodyPr wrap="square">
             <a:spAutoFit/>
           </a:bodyPr>
           <a:lstStyle/>
@@ -44172,7 +44214,7 @@
           <a:noFill/>
         </p:spPr>
         <p:txBody>
-          <a:bodyPr wrap="none">
+          <a:bodyPr wrap="square">
             <a:spAutoFit/>
           </a:bodyPr>
           <a:lstStyle/>
@@ -45575,7 +45617,7 @@
           <a:noFill/>
         </p:spPr>
         <p:txBody>
-          <a:bodyPr wrap="none">
+          <a:bodyPr wrap="square">
             <a:spAutoFit/>
           </a:bodyPr>
           <a:lstStyle/>
@@ -46561,7 +46603,7 @@
           <a:noFill/>
         </p:spPr>
         <p:txBody>
-          <a:bodyPr wrap="none">
+          <a:bodyPr wrap="square">
             <a:spAutoFit/>
           </a:bodyPr>
           <a:lstStyle/>
@@ -46961,7 +47003,7 @@
           <a:noFill/>
         </p:spPr>
         <p:txBody>
-          <a:bodyPr wrap="none">
+          <a:bodyPr wrap="square">
             <a:spAutoFit/>
           </a:bodyPr>
           <a:lstStyle/>
@@ -47301,7 +47343,7 @@
           <a:noFill/>
         </p:spPr>
         <p:txBody>
-          <a:bodyPr wrap="none">
+          <a:bodyPr wrap="square">
             <a:spAutoFit/>
           </a:bodyPr>
           <a:lstStyle/>
@@ -50724,7 +50766,7 @@
           <a:noFill/>
         </p:spPr>
         <p:txBody>
-          <a:bodyPr wrap="none">
+          <a:bodyPr wrap="square">
             <a:spAutoFit/>
           </a:bodyPr>
           <a:lstStyle/>
@@ -55450,7 +55492,28 @@
               </a:defRPr>
             </a:pPr>
             <a:r>
-              <a:t>When uncertain, Claude Code asks first.\n\nSafety &gt; Speed.</a:t>
+              <a:t>When uncertain, Claude Code asks first.</a:t>
+            </a:r>
+          </a:p>
+          <a:p>
+            <a:pPr>
+              <a:defRPr sz="2400">
+                <a:solidFill>
+                  <a:srgbClr val="8B95A5"/>
+                </a:solidFill>
+              </a:defRPr>
+            </a:pPr>
+          </a:p>
+          <a:p>
+            <a:pPr>
+              <a:defRPr sz="2400">
+                <a:solidFill>
+                  <a:srgbClr val="8B95A5"/>
+                </a:solidFill>
+              </a:defRPr>
+            </a:pPr>
+            <a:r>
+              <a:t>Safety &gt; Speed.</a:t>
             </a:r>
           </a:p>
         </p:txBody>
@@ -60357,7 +60420,7 @@
           <a:noFill/>
         </p:spPr>
         <p:txBody>
-          <a:bodyPr wrap="none">
+          <a:bodyPr wrap="square">
             <a:spAutoFit/>
           </a:bodyPr>
           <a:lstStyle/>

</xml_diff>

<commit_message>
fix: replace text icons with emoji on Trust Levels and Multi-Database slides
</commit_message>
<xml_diff>
--- a/slides/Day2_Claude_Code_Fundamentals.pptx
+++ b/slides/Day2_Claude_Code_Fundamentals.pptx
@@ -24558,14 +24558,14 @@
           <a:lstStyle/>
           <a:p>
             <a:pPr algn="ctr">
-              <a:defRPr sz="3600" b="1">
+              <a:defRPr sz="2800" b="1">
                 <a:solidFill>
                   <a:srgbClr val="0B0F1A"/>
                 </a:solidFill>
               </a:defRPr>
             </a:pPr>
             <a:r>
-              <a:t>database</a:t>
+              <a:t>🗄</a:t>
             </a:r>
           </a:p>
         </p:txBody>
@@ -24718,14 +24718,14 @@
           <a:lstStyle/>
           <a:p>
             <a:pPr algn="ctr">
-              <a:defRPr sz="3600" b="1">
+              <a:defRPr sz="2800" b="1">
                 <a:solidFill>
                   <a:srgbClr val="0B0F1A"/>
                 </a:solidFill>
               </a:defRPr>
             </a:pPr>
             <a:r>
-              <a:t>database</a:t>
+              <a:t>🗄</a:t>
             </a:r>
           </a:p>
         </p:txBody>
@@ -24878,14 +24878,14 @@
           <a:lstStyle/>
           <a:p>
             <a:pPr algn="ctr">
-              <a:defRPr sz="3600" b="1">
+              <a:defRPr sz="2800" b="1">
                 <a:solidFill>
                   <a:srgbClr val="0B0F1A"/>
                 </a:solidFill>
               </a:defRPr>
             </a:pPr>
             <a:r>
-              <a:t>database</a:t>
+              <a:t>🗄</a:t>
             </a:r>
           </a:p>
         </p:txBody>
@@ -55774,14 +55774,14 @@
           <a:lstStyle/>
           <a:p>
             <a:pPr algn="ctr">
-              <a:defRPr sz="3600" b="1">
+              <a:defRPr sz="2800" b="1">
                 <a:solidFill>
                   <a:srgbClr val="0B0F1A"/>
                 </a:solidFill>
               </a:defRPr>
             </a:pPr>
             <a:r>
-              <a:t>eye</a:t>
+              <a:t>👁</a:t>
             </a:r>
           </a:p>
         </p:txBody>
@@ -55934,14 +55934,14 @@
           <a:lstStyle/>
           <a:p>
             <a:pPr algn="ctr">
-              <a:defRPr sz="3600" b="1">
+              <a:defRPr sz="2800" b="1">
                 <a:solidFill>
                   <a:srgbClr val="0B0F1A"/>
                 </a:solidFill>
               </a:defRPr>
             </a:pPr>
             <a:r>
-              <a:t>book</a:t>
+              <a:t>📖</a:t>
             </a:r>
           </a:p>
         </p:txBody>
@@ -56094,14 +56094,14 @@
           <a:lstStyle/>
           <a:p>
             <a:pPr algn="ctr">
-              <a:defRPr sz="3600" b="1">
+              <a:defRPr sz="2800" b="1">
                 <a:solidFill>
                   <a:srgbClr val="0B0F1A"/>
                 </a:solidFill>
               </a:defRPr>
             </a:pPr>
             <a:r>
-              <a:t>zap</a:t>
+              <a:t>⚡</a:t>
             </a:r>
           </a:p>
         </p:txBody>

</xml_diff>

<commit_message>
fix: update installation from npm to native installer (curl)
npm install -g @anthropic-ai/claude-code is deprecated.
New methods: curl install.sh (auto-updates), Homebrew, WinGet.
Updated: slides 10-11, both Day 2 lab PDFs.
</commit_message>
<xml_diff>
--- a/slides/Day2_Claude_Code_Fundamentals.pptx
+++ b/slides/Day2_Claude_Code_Fundamentals.pptx
@@ -254,11 +254,41 @@
 <pc:chgInfo xmlns:a="http://schemas.openxmlformats.org/drawingml/2006/main" xmlns:r="http://schemas.openxmlformats.org/officeDocument/2006/relationships" xmlns:ac="http://schemas.microsoft.com/office/drawing/2013/main/command" xmlns:pc="http://schemas.microsoft.com/office/powerpoint/2013/main/command">
   <pc:docChgLst>
     <pc:chgData name="Scott Hay" userId="e95d3f44-f6c0-414c-b281-41a9346c1b81" providerId="ADAL" clId="{4D76341F-F64C-4A8E-A4EF-1A11730F38E9}"/>
-    <pc:docChg chg="custSel modSld">
-      <pc:chgData name="Scott Hay" userId="e95d3f44-f6c0-414c-b281-41a9346c1b81" providerId="ADAL" clId="{4D76341F-F64C-4A8E-A4EF-1A11730F38E9}" dt="2026-03-01T23:12:00.985" v="59" actId="478"/>
+    <pc:docChg chg="undo custSel modSld">
+      <pc:chgData name="Scott Hay" userId="e95d3f44-f6c0-414c-b281-41a9346c1b81" providerId="ADAL" clId="{4D76341F-F64C-4A8E-A4EF-1A11730F38E9}" dt="2026-03-02T00:51:44.576" v="63" actId="20577"/>
       <pc:docMkLst>
         <pc:docMk/>
       </pc:docMkLst>
+      <pc:sldChg chg="modSp mod">
+        <pc:chgData name="Scott Hay" userId="e95d3f44-f6c0-414c-b281-41a9346c1b81" providerId="ADAL" clId="{4D76341F-F64C-4A8E-A4EF-1A11730F38E9}" dt="2026-03-02T00:51:04.186" v="61" actId="20577"/>
+        <pc:sldMkLst>
+          <pc:docMk/>
+          <pc:sldMk cId="0" sldId="256"/>
+        </pc:sldMkLst>
+        <pc:spChg chg="mod">
+          <ac:chgData name="Scott Hay" userId="e95d3f44-f6c0-414c-b281-41a9346c1b81" providerId="ADAL" clId="{4D76341F-F64C-4A8E-A4EF-1A11730F38E9}" dt="2026-03-02T00:51:04.186" v="61" actId="20577"/>
+          <ac:spMkLst>
+            <pc:docMk/>
+            <pc:sldMk cId="0" sldId="256"/>
+            <ac:spMk id="4" creationId="{00000000-0000-0000-0000-000000000000}"/>
+          </ac:spMkLst>
+        </pc:spChg>
+      </pc:sldChg>
+      <pc:sldChg chg="modSp mod">
+        <pc:chgData name="Scott Hay" userId="e95d3f44-f6c0-414c-b281-41a9346c1b81" providerId="ADAL" clId="{4D76341F-F64C-4A8E-A4EF-1A11730F38E9}" dt="2026-03-02T00:51:44.576" v="63" actId="20577"/>
+        <pc:sldMkLst>
+          <pc:docMk/>
+          <pc:sldMk cId="0" sldId="263"/>
+        </pc:sldMkLst>
+        <pc:spChg chg="mod">
+          <ac:chgData name="Scott Hay" userId="e95d3f44-f6c0-414c-b281-41a9346c1b81" providerId="ADAL" clId="{4D76341F-F64C-4A8E-A4EF-1A11730F38E9}" dt="2026-03-02T00:51:44.576" v="63" actId="20577"/>
+          <ac:spMkLst>
+            <pc:docMk/>
+            <pc:sldMk cId="0" sldId="263"/>
+            <ac:spMk id="4" creationId="{00000000-0000-0000-0000-000000000000}"/>
+          </ac:spMkLst>
+        </pc:spChg>
+      </pc:sldChg>
       <pc:sldChg chg="modSp mod">
         <pc:chgData name="Scott Hay" userId="e95d3f44-f6c0-414c-b281-41a9346c1b81" providerId="ADAL" clId="{4D76341F-F64C-4A8E-A4EF-1A11730F38E9}" dt="2026-03-01T23:11:55.081" v="58" actId="27636"/>
         <pc:sldMkLst>
@@ -20097,8 +20127,8 @@
         </p:nvSpPr>
         <p:spPr>
           <a:xfrm>
-            <a:off x="457200" y="5029200"/>
-            <a:ext cx="11277295" cy="457200"/>
+            <a:off x="9456307" y="5029200"/>
+            <a:ext cx="2278188" cy="400110"/>
           </a:xfrm>
           <a:prstGeom prst="rect">
             <a:avLst/>
@@ -20119,7 +20149,8 @@
               </a:defRPr>
             </a:pPr>
             <a:r>
-              <a:t>- © 2026 AIA Copilot</a:t>
+              <a:rPr dirty="0"/>
+              <a:t>© 2026 AIA Copilot</a:t>
             </a:r>
           </a:p>
         </p:txBody>
@@ -20706,37 +20737,136 @@
           <a:lstStyle/>
           <a:p>
             <a:pPr algn="ctr">
-              <a:defRPr sz="1800" b="1">
-                <a:solidFill>
-                  <a:srgbClr val="FFFFFF"/>
-                </a:solidFill>
-              </a:defRPr>
-            </a:pPr>
-            <a:r>
-              <a:t>Account</a:t>
-            </a:r>
-          </a:p>
-          <a:p>
-            <a:pPr algn="ctr">
-              <a:spcBef>
-                <a:spcPts val="800"/>
-              </a:spcBef>
-              <a:defRPr sz="1300">
-                <a:solidFill>
-                  <a:srgbClr val="8B95A5"/>
-                </a:solidFill>
-              </a:defRPr>
-            </a:pPr>
-            <a:r>
-              <a:t>Anthropic account (Pro or Max plan)</a:t>
-            </a:r>
-            <a:br/>
-            <a:r>
-              <a:t>Claude Code CLI: npm install -g @anthropic-ai/claude-code</a:t>
-            </a:r>
-            <a:br/>
-            <a:r>
-              <a:t>Authenticate: claude login</a:t>
+              <a:defRPr sz="1400" b="1">
+                <a:solidFill>
+                  <a:srgbClr val="F8F8F2"/>
+                </a:solidFill>
+                <a:latin typeface="Consolas"/>
+              </a:defRPr>
+            </a:pPr>
+            <a:r>
+              <a:t># Method 1: Native install (recommended — auto-updates)</a:t>
+            </a:r>
+          </a:p>
+          <a:p>
+            <a:pPr>
+              <a:defRPr sz="1400">
+                <a:solidFill>
+                  <a:srgbClr val="F8F8F2"/>
+                </a:solidFill>
+                <a:latin typeface="Consolas"/>
+              </a:defRPr>
+            </a:pPr>
+            <a:r>
+              <a:t>curl -fsSL https://claude.ai/install.sh | bash</a:t>
+            </a:r>
+          </a:p>
+          <a:p>
+            <a:pPr>
+              <a:defRPr sz="1400">
+                <a:solidFill>
+                  <a:srgbClr val="F8F8F2"/>
+                </a:solidFill>
+                <a:latin typeface="Consolas"/>
+              </a:defRPr>
+            </a:pPr>
+          </a:p>
+          <a:p>
+            <a:pPr>
+              <a:defRPr sz="1400">
+                <a:solidFill>
+                  <a:srgbClr val="F8F8F2"/>
+                </a:solidFill>
+                <a:latin typeface="Consolas"/>
+              </a:defRPr>
+            </a:pPr>
+            <a:r>
+              <a:t># Method 2: Homebrew (macOS/Linux — manual updates)</a:t>
+            </a:r>
+          </a:p>
+          <a:p>
+            <a:pPr>
+              <a:defRPr sz="1400">
+                <a:solidFill>
+                  <a:srgbClr val="F8F8F2"/>
+                </a:solidFill>
+                <a:latin typeface="Consolas"/>
+              </a:defRPr>
+            </a:pPr>
+            <a:r>
+              <a:t>brew install --cask claude-code</a:t>
+            </a:r>
+          </a:p>
+          <a:p>
+            <a:pPr>
+              <a:defRPr sz="1400">
+                <a:solidFill>
+                  <a:srgbClr val="F8F8F2"/>
+                </a:solidFill>
+                <a:latin typeface="Consolas"/>
+              </a:defRPr>
+            </a:pPr>
+          </a:p>
+          <a:p>
+            <a:pPr>
+              <a:defRPr sz="1400">
+                <a:solidFill>
+                  <a:srgbClr val="F8F8F2"/>
+                </a:solidFill>
+                <a:latin typeface="Consolas"/>
+              </a:defRPr>
+            </a:pPr>
+            <a:r>
+              <a:t># Method 3: WinGet (Windows — manual updates)</a:t>
+            </a:r>
+          </a:p>
+          <a:p>
+            <a:pPr>
+              <a:defRPr sz="1400">
+                <a:solidFill>
+                  <a:srgbClr val="F8F8F2"/>
+                </a:solidFill>
+                <a:latin typeface="Consolas"/>
+              </a:defRPr>
+            </a:pPr>
+            <a:r>
+              <a:t>winget install Anthropic.ClaudeCode</a:t>
+            </a:r>
+          </a:p>
+          <a:p>
+            <a:pPr>
+              <a:defRPr sz="1400">
+                <a:solidFill>
+                  <a:srgbClr val="F8F8F2"/>
+                </a:solidFill>
+                <a:latin typeface="Consolas"/>
+              </a:defRPr>
+            </a:pPr>
+          </a:p>
+          <a:p>
+            <a:pPr>
+              <a:defRPr sz="1400">
+                <a:solidFill>
+                  <a:srgbClr val="F8F8F2"/>
+                </a:solidFill>
+                <a:latin typeface="Consolas"/>
+              </a:defRPr>
+            </a:pPr>
+            <a:r>
+              <a:t># Verify installation</a:t>
+            </a:r>
+          </a:p>
+          <a:p>
+            <a:pPr>
+              <a:defRPr sz="1400">
+                <a:solidFill>
+                  <a:srgbClr val="F8F8F2"/>
+                </a:solidFill>
+                <a:latin typeface="Consolas"/>
+              </a:defRPr>
+            </a:pPr>
+            <a:r>
+              <a:t>claude --version</a:t>
             </a:r>
           </a:p>
         </p:txBody>
@@ -24242,118 +24372,115 @@
             <a:pPr>
               <a:defRPr sz="1400">
                 <a:solidFill>
-                  <a:srgbClr val="FFFFFF"/>
+                  <a:srgbClr val="F8F8F2"/>
                 </a:solidFill>
                 <a:latin typeface="Consolas"/>
               </a:defRPr>
             </a:pPr>
             <a:r>
-              <a:t># Method 1: Global install via npm (recommended)</a:t>
+              <a:t># Method 1: Native install (recommended — auto-updates)</a:t>
             </a:r>
           </a:p>
           <a:p>
             <a:pPr>
               <a:defRPr sz="1400">
                 <a:solidFill>
-                  <a:srgbClr val="FFFFFF"/>
+                  <a:srgbClr val="F8F8F2"/>
                 </a:solidFill>
                 <a:latin typeface="Consolas"/>
               </a:defRPr>
             </a:pPr>
             <a:r>
-              <a:t>npm install -g @anthropic-ai/claude-code</a:t>
+              <a:t>curl -fsSL https://claude.ai/install.sh | bash</a:t>
             </a:r>
           </a:p>
           <a:p>
             <a:pPr>
               <a:defRPr sz="1400">
                 <a:solidFill>
-                  <a:srgbClr val="FFFFFF"/>
+                  <a:srgbClr val="F8F8F2"/>
                 </a:solidFill>
                 <a:latin typeface="Consolas"/>
               </a:defRPr>
             </a:pPr>
-            <a:endParaRPr/>
           </a:p>
           <a:p>
             <a:pPr>
               <a:defRPr sz="1400">
                 <a:solidFill>
-                  <a:srgbClr val="FFFFFF"/>
+                  <a:srgbClr val="F8F8F2"/>
                 </a:solidFill>
                 <a:latin typeface="Consolas"/>
               </a:defRPr>
             </a:pPr>
             <a:r>
-              <a:t># Method 2: Homebrew (macOS/Linux)</a:t>
+              <a:t># Method 2: Homebrew (macOS/Linux — manual updates)</a:t>
             </a:r>
           </a:p>
           <a:p>
             <a:pPr>
               <a:defRPr sz="1400">
                 <a:solidFill>
-                  <a:srgbClr val="FFFFFF"/>
+                  <a:srgbClr val="F8F8F2"/>
                 </a:solidFill>
                 <a:latin typeface="Consolas"/>
               </a:defRPr>
             </a:pPr>
             <a:r>
-              <a:t>brew install claude-code</a:t>
+              <a:t>brew install --cask claude-code</a:t>
             </a:r>
           </a:p>
           <a:p>
             <a:pPr>
               <a:defRPr sz="1400">
                 <a:solidFill>
-                  <a:srgbClr val="FFFFFF"/>
+                  <a:srgbClr val="F8F8F2"/>
                 </a:solidFill>
                 <a:latin typeface="Consolas"/>
               </a:defRPr>
             </a:pPr>
-            <a:endParaRPr/>
           </a:p>
           <a:p>
             <a:pPr>
               <a:defRPr sz="1400">
                 <a:solidFill>
-                  <a:srgbClr val="FFFFFF"/>
+                  <a:srgbClr val="F8F8F2"/>
                 </a:solidFill>
                 <a:latin typeface="Consolas"/>
               </a:defRPr>
             </a:pPr>
             <a:r>
-              <a:t># Method 3: npx (no install, always latest)</a:t>
+              <a:t># Method 3: WinGet (Windows — manual updates)</a:t>
             </a:r>
           </a:p>
           <a:p>
             <a:pPr>
               <a:defRPr sz="1400">
                 <a:solidFill>
-                  <a:srgbClr val="FFFFFF"/>
+                  <a:srgbClr val="F8F8F2"/>
                 </a:solidFill>
                 <a:latin typeface="Consolas"/>
               </a:defRPr>
             </a:pPr>
             <a:r>
-              <a:t>npx @anthropic-ai/claude-code</a:t>
+              <a:t>winget install Anthropic.ClaudeCode</a:t>
             </a:r>
           </a:p>
           <a:p>
             <a:pPr>
               <a:defRPr sz="1400">
                 <a:solidFill>
-                  <a:srgbClr val="FFFFFF"/>
+                  <a:srgbClr val="F8F8F2"/>
                 </a:solidFill>
                 <a:latin typeface="Consolas"/>
               </a:defRPr>
             </a:pPr>
-            <a:endParaRPr/>
           </a:p>
           <a:p>
             <a:pPr>
               <a:defRPr sz="1400">
                 <a:solidFill>
-                  <a:srgbClr val="FFFFFF"/>
+                  <a:srgbClr val="F8F8F2"/>
                 </a:solidFill>
                 <a:latin typeface="Consolas"/>
               </a:defRPr>
@@ -24366,7 +24493,7 @@
             <a:pPr>
               <a:defRPr sz="1400">
                 <a:solidFill>
-                  <a:srgbClr val="FFFFFF"/>
+                  <a:srgbClr val="F8F8F2"/>
                 </a:solidFill>
                 <a:latin typeface="Consolas"/>
               </a:defRPr>
@@ -56667,6 +56794,7 @@
               </a:defRPr>
             </a:pPr>
             <a:r>
+              <a:rPr dirty="0"/>
               <a:t>  Working memory → Context window: Both degrade under load.</a:t>
             </a:r>
           </a:p>
@@ -56685,6 +56813,7 @@
               </a:defRPr>
             </a:pPr>
             <a:r>
+              <a:rPr dirty="0"/>
               <a:t>  Short-term → Session history: When you study, you move important things from short-term to long-term memory through n...</a:t>
             </a:r>
           </a:p>
@@ -56703,6 +56832,7 @@
               </a:defRPr>
             </a:pPr>
             <a:r>
+              <a:rPr dirty="0"/>
               <a:t>  Long-term → CLAUDE.</a:t>
             </a:r>
           </a:p>
@@ -56721,8 +56851,10 @@
               </a:defRPr>
             </a:pPr>
             <a:r>
+              <a:rPr dirty="0"/>
               <a:t>  Muscle memory → Skills / custom commands: Just like you don't consciously think about typing, skills and commands let...</a:t>
             </a:r>
+            <a:endParaRPr lang="en-US" dirty="0"/>
           </a:p>
           <a:p>
             <a:pPr>
@@ -56739,6 +56871,7 @@
               </a:defRPr>
             </a:pPr>
             <a:r>
+              <a:rPr lang="en-US" dirty="0"/>
               <a:t>  Scott's framing: Context window is short-term memory.</a:t>
             </a:r>
           </a:p>
@@ -56757,6 +56890,7 @@
               </a:defRPr>
             </a:pPr>
             <a:r>
+              <a:rPr lang="en-US" dirty="0"/>
               <a:t>  Everything that follows today — CLAUDE.</a:t>
             </a:r>
           </a:p>

</xml_diff>

<commit_message>
fix: slide 10 card 3 — replace code block with clean Account items
</commit_message>
<xml_diff>
--- a/slides/Day2_Claude_Code_Fundamentals.pptx
+++ b/slides/Day2_Claude_Code_Fundamentals.pptx
@@ -245,7 +245,7 @@
 <file path=ppt/revisionInfo.xml><?xml version="1.0" encoding="utf-8"?>
 <p1510:revInfo xmlns:a="http://schemas.openxmlformats.org/drawingml/2006/main" xmlns:r="http://schemas.openxmlformats.org/officeDocument/2006/relationships" xmlns:p1510="http://schemas.microsoft.com/office/powerpoint/2015/10/main">
   <p1510:revLst>
-    <p1510:client id="{E139C36B-8AB1-447E-AA47-07FFCAD28EDF}" v="1" dt="2026-03-01T23:11:54.861"/>
+    <p1510:client id="{E139C36B-8AB1-447E-AA47-07FFCAD28EDF}" v="2" dt="2026-03-02T01:49:24.476"/>
   </p1510:revLst>
 </p1510:revInfo>
 </file>
@@ -255,7 +255,7 @@
   <pc:docChgLst>
     <pc:chgData name="Scott Hay" userId="e95d3f44-f6c0-414c-b281-41a9346c1b81" providerId="ADAL" clId="{4D76341F-F64C-4A8E-A4EF-1A11730F38E9}"/>
     <pc:docChg chg="undo custSel modSld">
-      <pc:chgData name="Scott Hay" userId="e95d3f44-f6c0-414c-b281-41a9346c1b81" providerId="ADAL" clId="{4D76341F-F64C-4A8E-A4EF-1A11730F38E9}" dt="2026-03-02T00:51:44.576" v="63" actId="20577"/>
+      <pc:chgData name="Scott Hay" userId="e95d3f44-f6c0-414c-b281-41a9346c1b81" providerId="ADAL" clId="{4D76341F-F64C-4A8E-A4EF-1A11730F38E9}" dt="2026-03-02T01:49:32.898" v="82" actId="108"/>
       <pc:docMkLst>
         <pc:docMk/>
       </pc:docMkLst>
@@ -290,7 +290,7 @@
         </pc:spChg>
       </pc:sldChg>
       <pc:sldChg chg="modSp mod">
-        <pc:chgData name="Scott Hay" userId="e95d3f44-f6c0-414c-b281-41a9346c1b81" providerId="ADAL" clId="{4D76341F-F64C-4A8E-A4EF-1A11730F38E9}" dt="2026-03-01T23:11:55.081" v="58" actId="27636"/>
+        <pc:chgData name="Scott Hay" userId="e95d3f44-f6c0-414c-b281-41a9346c1b81" providerId="ADAL" clId="{4D76341F-F64C-4A8E-A4EF-1A11730F38E9}" dt="2026-03-02T01:49:32.898" v="82" actId="108"/>
         <pc:sldMkLst>
           <pc:docMk/>
           <pc:sldMk cId="0" sldId="265"/>
@@ -304,7 +304,15 @@
           </ac:spMkLst>
         </pc:spChg>
         <pc:spChg chg="mod">
-          <ac:chgData name="Scott Hay" userId="e95d3f44-f6c0-414c-b281-41a9346c1b81" providerId="ADAL" clId="{4D76341F-F64C-4A8E-A4EF-1A11730F38E9}" dt="2026-03-01T23:11:55.081" v="58" actId="27636"/>
+          <ac:chgData name="Scott Hay" userId="e95d3f44-f6c0-414c-b281-41a9346c1b81" providerId="ADAL" clId="{4D76341F-F64C-4A8E-A4EF-1A11730F38E9}" dt="2026-03-02T01:48:51.608" v="65" actId="14100"/>
+          <ac:spMkLst>
+            <pc:docMk/>
+            <pc:sldMk cId="0" sldId="265"/>
+            <ac:spMk id="11" creationId="{00000000-0000-0000-0000-000000000000}"/>
+          </ac:spMkLst>
+        </pc:spChg>
+        <pc:spChg chg="mod">
+          <ac:chgData name="Scott Hay" userId="e95d3f44-f6c0-414c-b281-41a9346c1b81" providerId="ADAL" clId="{4D76341F-F64C-4A8E-A4EF-1A11730F38E9}" dt="2026-03-02T01:49:32.898" v="82" actId="108"/>
           <ac:spMkLst>
             <pc:docMk/>
             <pc:sldMk cId="0" sldId="265"/>
@@ -883,7 +891,7 @@
         </pc:spChg>
       </pc:sldChg>
       <pc:sldChg chg="modSp mod">
-        <pc:chgData name="Scott Hay" userId="e95d3f44-f6c0-414c-b281-41a9346c1b81" providerId="ADAL" clId="{4D76341F-F64C-4A8E-A4EF-1A11730F38E9}" dt="2026-03-01T23:11:55.045" v="47" actId="27636"/>
+        <pc:chgData name="Scott Hay" userId="e95d3f44-f6c0-414c-b281-41a9346c1b81" providerId="ADAL" clId="{4D76341F-F64C-4A8E-A4EF-1A11730F38E9}" dt="2026-03-02T01:49:24.526" v="76" actId="27636"/>
         <pc:sldMkLst>
           <pc:docMk/>
           <pc:sldMk cId="0" sldId="350"/>
@@ -913,7 +921,7 @@
           </ac:spMkLst>
         </pc:spChg>
         <pc:spChg chg="mod">
-          <ac:chgData name="Scott Hay" userId="e95d3f44-f6c0-414c-b281-41a9346c1b81" providerId="ADAL" clId="{4D76341F-F64C-4A8E-A4EF-1A11730F38E9}" dt="2026-03-01T23:11:55.045" v="47" actId="27636"/>
+          <ac:chgData name="Scott Hay" userId="e95d3f44-f6c0-414c-b281-41a9346c1b81" providerId="ADAL" clId="{4D76341F-F64C-4A8E-A4EF-1A11730F38E9}" dt="2026-03-02T01:49:24.526" v="76" actId="27636"/>
           <ac:spMkLst>
             <pc:docMk/>
             <pc:sldMk cId="0" sldId="350"/>
@@ -20561,6 +20569,7 @@
               </a:defRPr>
             </a:pPr>
             <a:r>
+              <a:rPr dirty="0"/>
               <a:t>Tools</a:t>
             </a:r>
           </a:p>
@@ -20576,14 +20585,21 @@
               </a:defRPr>
             </a:pPr>
             <a:r>
+              <a:rPr dirty="0"/>
               <a:t>Terminal (iTerm2, Windows Terminal, etc.)</a:t>
             </a:r>
-            <a:br/>
-            <a:r>
+            <a:br>
+              <a:rPr dirty="0"/>
+            </a:br>
+            <a:r>
+              <a:rPr dirty="0"/>
               <a:t>Git installed and configured</a:t>
             </a:r>
-            <a:br/>
-            <a:r>
+            <a:br>
+              <a:rPr dirty="0"/>
+            </a:br>
+            <a:r>
+              <a:rPr dirty="0"/>
               <a:t>VS Code or JetBrains IDE (optional)</a:t>
             </a:r>
           </a:p>
@@ -20598,7 +20614,7 @@
         <p:spPr>
           <a:xfrm>
             <a:off x="7604607" y="2011680"/>
-            <a:ext cx="2286000" cy="3200400"/>
+            <a:ext cx="2970628" cy="4846320"/>
           </a:xfrm>
           <a:prstGeom prst="roundRect">
             <a:avLst/>
@@ -20723,7 +20739,7 @@
         <p:spPr>
           <a:xfrm>
             <a:off x="7696047" y="3657600"/>
-            <a:ext cx="2103120" cy="1371600"/>
+            <a:ext cx="2879188" cy="1371600"/>
           </a:xfrm>
           <a:prstGeom prst="rect">
             <a:avLst/>
@@ -20732,141 +20748,65 @@
         </p:spPr>
         <p:txBody>
           <a:bodyPr wrap="square">
-            <a:normAutofit fontScale="92500"/>
+            <a:noAutofit/>
           </a:bodyPr>
           <a:lstStyle/>
           <a:p>
             <a:pPr algn="ctr">
-              <a:defRPr sz="1400" b="1">
-                <a:solidFill>
-                  <a:srgbClr val="F8F8F2"/>
+              <a:defRPr sz="1800" b="1">
+                <a:solidFill>
+                  <a:srgbClr val="FFFFFF"/>
                 </a:solidFill>
                 <a:latin typeface="Consolas"/>
               </a:defRPr>
             </a:pPr>
             <a:r>
-              <a:t># Method 1: Native install (recommended — auto-updates)</a:t>
-            </a:r>
-          </a:p>
-          <a:p>
-            <a:pPr>
-              <a:defRPr sz="1400">
-                <a:solidFill>
-                  <a:srgbClr val="F8F8F2"/>
-                </a:solidFill>
-                <a:latin typeface="Consolas"/>
-              </a:defRPr>
-            </a:pPr>
-            <a:r>
-              <a:t>curl -fsSL https://claude.ai/install.sh | bash</a:t>
-            </a:r>
-          </a:p>
-          <a:p>
-            <a:pPr>
-              <a:defRPr sz="1400">
-                <a:solidFill>
-                  <a:srgbClr val="F8F8F2"/>
-                </a:solidFill>
-                <a:latin typeface="Consolas"/>
-              </a:defRPr>
-            </a:pPr>
-          </a:p>
-          <a:p>
-            <a:pPr>
-              <a:defRPr sz="1400">
-                <a:solidFill>
-                  <a:srgbClr val="F8F8F2"/>
-                </a:solidFill>
-                <a:latin typeface="Consolas"/>
-              </a:defRPr>
-            </a:pPr>
-            <a:r>
-              <a:t># Method 2: Homebrew (macOS/Linux — manual updates)</a:t>
-            </a:r>
-          </a:p>
-          <a:p>
-            <a:pPr>
-              <a:defRPr sz="1400">
-                <a:solidFill>
-                  <a:srgbClr val="F8F8F2"/>
-                </a:solidFill>
-                <a:latin typeface="Consolas"/>
-              </a:defRPr>
-            </a:pPr>
-            <a:r>
-              <a:t>brew install --cask claude-code</a:t>
-            </a:r>
-          </a:p>
-          <a:p>
-            <a:pPr>
-              <a:defRPr sz="1400">
-                <a:solidFill>
-                  <a:srgbClr val="F8F8F2"/>
-                </a:solidFill>
-                <a:latin typeface="Consolas"/>
-              </a:defRPr>
-            </a:pPr>
-          </a:p>
-          <a:p>
-            <a:pPr>
-              <a:defRPr sz="1400">
-                <a:solidFill>
-                  <a:srgbClr val="F8F8F2"/>
-                </a:solidFill>
-                <a:latin typeface="Consolas"/>
-              </a:defRPr>
-            </a:pPr>
-            <a:r>
-              <a:t># Method 3: WinGet (Windows — manual updates)</a:t>
-            </a:r>
-          </a:p>
-          <a:p>
-            <a:pPr>
-              <a:defRPr sz="1400">
-                <a:solidFill>
-                  <a:srgbClr val="F8F8F2"/>
-                </a:solidFill>
-                <a:latin typeface="Consolas"/>
-              </a:defRPr>
-            </a:pPr>
-            <a:r>
-              <a:t>winget install Anthropic.ClaudeCode</a:t>
-            </a:r>
-          </a:p>
-          <a:p>
-            <a:pPr>
-              <a:defRPr sz="1400">
-                <a:solidFill>
-                  <a:srgbClr val="F8F8F2"/>
-                </a:solidFill>
-                <a:latin typeface="Consolas"/>
-              </a:defRPr>
-            </a:pPr>
-          </a:p>
-          <a:p>
-            <a:pPr>
-              <a:defRPr sz="1400">
-                <a:solidFill>
-                  <a:srgbClr val="F8F8F2"/>
-                </a:solidFill>
-                <a:latin typeface="Consolas"/>
-              </a:defRPr>
-            </a:pPr>
-            <a:r>
-              <a:t># Verify installation</a:t>
-            </a:r>
-          </a:p>
-          <a:p>
-            <a:pPr>
-              <a:defRPr sz="1400">
-                <a:solidFill>
-                  <a:srgbClr val="F8F8F2"/>
-                </a:solidFill>
-                <a:latin typeface="Consolas"/>
-              </a:defRPr>
-            </a:pPr>
-            <a:r>
-              <a:t>claude --version</a:t>
+              <a:t>Account</a:t>
+            </a:r>
+          </a:p>
+          <a:p>
+            <a:pPr algn="ctr">
+              <a:spcBef>
+                <a:spcPts val="400"/>
+              </a:spcBef>
+              <a:defRPr sz="1100">
+                <a:solidFill>
+                  <a:srgbClr val="8A8F98"/>
+                </a:solidFill>
+              </a:defRPr>
+            </a:pPr>
+            <a:r>
+              <a:t>Anthropic Pro or Max plan</a:t>
+            </a:r>
+          </a:p>
+          <a:p>
+            <a:pPr algn="ctr">
+              <a:spcBef>
+                <a:spcPts val="400"/>
+              </a:spcBef>
+              <a:defRPr sz="1100">
+                <a:solidFill>
+                  <a:srgbClr val="8A8F98"/>
+                </a:solidFill>
+              </a:defRPr>
+            </a:pPr>
+            <a:r>
+              <a:t>Install: claude.ai/install.sh</a:t>
+            </a:r>
+          </a:p>
+          <a:p>
+            <a:pPr algn="ctr">
+              <a:spcBef>
+                <a:spcPts val="400"/>
+              </a:spcBef>
+              <a:defRPr sz="1100">
+                <a:solidFill>
+                  <a:srgbClr val="8A8F98"/>
+                </a:solidFill>
+              </a:defRPr>
+            </a:pPr>
+            <a:r>
+              <a:t>Authenticate: claude login</a:t>
             </a:r>
           </a:p>
         </p:txBody>
@@ -24403,6 +24343,7 @@
                 <a:latin typeface="Consolas"/>
               </a:defRPr>
             </a:pPr>
+            <a:endParaRPr/>
           </a:p>
           <a:p>
             <a:pPr>
@@ -24439,6 +24380,7 @@
                 <a:latin typeface="Consolas"/>
               </a:defRPr>
             </a:pPr>
+            <a:endParaRPr/>
           </a:p>
           <a:p>
             <a:pPr>
@@ -24475,6 +24417,7 @@
                 <a:latin typeface="Consolas"/>
               </a:defRPr>
             </a:pPr>
+            <a:endParaRPr/>
           </a:p>
           <a:p>
             <a:pPr>
@@ -61798,7 +61741,7 @@
         </p:spPr>
         <p:txBody>
           <a:bodyPr wrap="square">
-            <a:normAutofit fontScale="92500"/>
+            <a:normAutofit lnSpcReduction="10000"/>
           </a:bodyPr>
           <a:lstStyle/>
           <a:p>

</xml_diff>

<commit_message>
fix: slide 8 Memory Architecture — clean 4-row comparison layout
</commit_message>
<xml_diff>
--- a/slides/Day2_Claude_Code_Fundamentals.pptx
+++ b/slides/Day2_Claude_Code_Fundamentals.pptx
@@ -56709,8 +56709,8 @@
         </p:nvSpPr>
         <p:spPr>
           <a:xfrm>
-            <a:off x="457200" y="1463040"/>
-            <a:ext cx="11277295" cy="4572000"/>
+            <a:off x="914400" y="1828800"/>
+            <a:ext cx="3200400" cy="822960"/>
           </a:xfrm>
           <a:prstGeom prst="rect">
             <a:avLst/>
@@ -56723,118 +56723,435 @@
           </a:bodyPr>
           <a:lstStyle/>
           <a:p>
-            <a:pPr>
-              <a:spcBef>
-                <a:spcPts val="800"/>
-              </a:spcBef>
-              <a:spcAft>
-                <a:spcPts val="800"/>
-              </a:spcAft>
-              <a:defRPr sz="2200">
-                <a:solidFill>
-                  <a:srgbClr val="FFFFFF"/>
-                </a:solidFill>
-              </a:defRPr>
-            </a:pPr>
-            <a:r>
-              <a:rPr dirty="0"/>
-              <a:t>  Working memory → Context window: Both degrade under load.</a:t>
-            </a:r>
-          </a:p>
-          <a:p>
-            <a:pPr>
-              <a:spcBef>
-                <a:spcPts val="800"/>
-              </a:spcBef>
-              <a:spcAft>
-                <a:spcPts val="800"/>
-              </a:spcAft>
-              <a:defRPr sz="2200">
-                <a:solidFill>
-                  <a:srgbClr val="FFFFFF"/>
-                </a:solidFill>
-              </a:defRPr>
-            </a:pPr>
-            <a:r>
-              <a:rPr dirty="0"/>
-              <a:t>  Short-term → Session history: When you study, you move important things from short-term to long-term memory through n...</a:t>
-            </a:r>
-          </a:p>
-          <a:p>
-            <a:pPr>
-              <a:spcBef>
-                <a:spcPts val="800"/>
-              </a:spcBef>
-              <a:spcAft>
-                <a:spcPts val="800"/>
-              </a:spcAft>
-              <a:defRPr sz="2200">
-                <a:solidFill>
-                  <a:srgbClr val="FFFFFF"/>
-                </a:solidFill>
-              </a:defRPr>
-            </a:pPr>
-            <a:r>
-              <a:rPr dirty="0"/>
-              <a:t>  Long-term → CLAUDE.</a:t>
-            </a:r>
-          </a:p>
-          <a:p>
-            <a:pPr>
-              <a:spcBef>
-                <a:spcPts val="800"/>
-              </a:spcBef>
-              <a:spcAft>
-                <a:spcPts val="800"/>
-              </a:spcAft>
-              <a:defRPr sz="2200">
-                <a:solidFill>
-                  <a:srgbClr val="FFFFFF"/>
-                </a:solidFill>
-              </a:defRPr>
-            </a:pPr>
-            <a:r>
-              <a:rPr dirty="0"/>
-              <a:t>  Muscle memory → Skills / custom commands: Just like you don't consciously think about typing, skills and commands let...</a:t>
-            </a:r>
-            <a:endParaRPr lang="en-US" dirty="0"/>
-          </a:p>
-          <a:p>
-            <a:pPr>
-              <a:spcBef>
-                <a:spcPts val="800"/>
-              </a:spcBef>
-              <a:spcAft>
-                <a:spcPts val="800"/>
-              </a:spcAft>
-              <a:defRPr sz="2200">
-                <a:solidFill>
-                  <a:srgbClr val="FFFFFF"/>
-                </a:solidFill>
-              </a:defRPr>
-            </a:pPr>
-            <a:r>
-              <a:rPr lang="en-US" dirty="0"/>
-              <a:t>  Scott's framing: Context window is short-term memory.</a:t>
-            </a:r>
-          </a:p>
-          <a:p>
-            <a:pPr>
-              <a:spcBef>
-                <a:spcPts val="800"/>
-              </a:spcBef>
-              <a:spcAft>
-                <a:spcPts val="800"/>
-              </a:spcAft>
-              <a:defRPr sz="2200">
-                <a:solidFill>
-                  <a:srgbClr val="FFFFFF"/>
-                </a:solidFill>
-              </a:defRPr>
-            </a:pPr>
-            <a:r>
-              <a:rPr lang="en-US" dirty="0"/>
-              <a:t>  Everything that follows today — CLAUDE.</a:t>
+            <a:pPr algn="r">
+              <a:defRPr sz="2200" b="1">
+                <a:solidFill>
+                  <a:srgbClr val="FF6B6B"/>
+                </a:solidFill>
+              </a:defRPr>
+            </a:pPr>
+            <a:r>
+              <a:t>Working memory</a:t>
+            </a:r>
+          </a:p>
+        </p:txBody>
+      </p:sp>
+      <p:sp>
+        <p:nvSpPr>
+          <p:cNvPr id="5" name="TextBox 4"/>
+          <p:cNvSpPr txBox="1"/>
+          <p:nvPr/>
+        </p:nvSpPr>
+        <p:spPr>
+          <a:xfrm>
+            <a:off x="4297680" y="1828800"/>
+            <a:ext cx="731520" cy="822960"/>
+          </a:xfrm>
+          <a:prstGeom prst="rect">
+            <a:avLst/>
+          </a:prstGeom>
+          <a:noFill/>
+        </p:spPr>
+        <p:txBody>
+          <a:bodyPr wrap="none">
+            <a:spAutoFit/>
+          </a:bodyPr>
+          <a:lstStyle/>
+          <a:p>
+            <a:pPr algn="ctr">
+              <a:defRPr sz="2800">
+                <a:solidFill>
+                  <a:srgbClr val="8A8F98"/>
+                </a:solidFill>
+              </a:defRPr>
+            </a:pPr>
+            <a:r>
+              <a:t>→</a:t>
+            </a:r>
+          </a:p>
+        </p:txBody>
+      </p:sp>
+      <p:sp>
+        <p:nvSpPr>
+          <p:cNvPr id="6" name="TextBox 5"/>
+          <p:cNvSpPr txBox="1"/>
+          <p:nvPr/>
+        </p:nvSpPr>
+        <p:spPr>
+          <a:xfrm>
+            <a:off x="5212080" y="1828800"/>
+            <a:ext cx="3657600" cy="822960"/>
+          </a:xfrm>
+          <a:prstGeom prst="rect">
+            <a:avLst/>
+          </a:prstGeom>
+          <a:noFill/>
+        </p:spPr>
+        <p:txBody>
+          <a:bodyPr wrap="square">
+            <a:spAutoFit/>
+          </a:bodyPr>
+          <a:lstStyle/>
+          <a:p>
+            <a:pPr algn="l">
+              <a:defRPr sz="2200" b="1">
+                <a:solidFill>
+                  <a:srgbClr val="00D4AA"/>
+                </a:solidFill>
+              </a:defRPr>
+            </a:pPr>
+            <a:r>
+              <a:t>Context window</a:t>
+            </a:r>
+          </a:p>
+        </p:txBody>
+      </p:sp>
+      <p:sp>
+        <p:nvSpPr>
+          <p:cNvPr id="7" name="TextBox 6"/>
+          <p:cNvSpPr txBox="1"/>
+          <p:nvPr/>
+        </p:nvSpPr>
+        <p:spPr>
+          <a:xfrm>
+            <a:off x="914400" y="2651760"/>
+            <a:ext cx="3200400" cy="822960"/>
+          </a:xfrm>
+          <a:prstGeom prst="rect">
+            <a:avLst/>
+          </a:prstGeom>
+          <a:noFill/>
+        </p:spPr>
+        <p:txBody>
+          <a:bodyPr wrap="square">
+            <a:spAutoFit/>
+          </a:bodyPr>
+          <a:lstStyle/>
+          <a:p>
+            <a:pPr algn="r">
+              <a:defRPr sz="2200" b="1">
+                <a:solidFill>
+                  <a:srgbClr val="FF6B6B"/>
+                </a:solidFill>
+              </a:defRPr>
+            </a:pPr>
+            <a:r>
+              <a:t>Short-term memory</a:t>
+            </a:r>
+          </a:p>
+        </p:txBody>
+      </p:sp>
+      <p:sp>
+        <p:nvSpPr>
+          <p:cNvPr id="8" name="TextBox 7"/>
+          <p:cNvSpPr txBox="1"/>
+          <p:nvPr/>
+        </p:nvSpPr>
+        <p:spPr>
+          <a:xfrm>
+            <a:off x="4297680" y="2651760"/>
+            <a:ext cx="731520" cy="822960"/>
+          </a:xfrm>
+          <a:prstGeom prst="rect">
+            <a:avLst/>
+          </a:prstGeom>
+          <a:noFill/>
+        </p:spPr>
+        <p:txBody>
+          <a:bodyPr wrap="none">
+            <a:spAutoFit/>
+          </a:bodyPr>
+          <a:lstStyle/>
+          <a:p>
+            <a:pPr algn="ctr">
+              <a:defRPr sz="2800">
+                <a:solidFill>
+                  <a:srgbClr val="8A8F98"/>
+                </a:solidFill>
+              </a:defRPr>
+            </a:pPr>
+            <a:r>
+              <a:t>→</a:t>
+            </a:r>
+          </a:p>
+        </p:txBody>
+      </p:sp>
+      <p:sp>
+        <p:nvSpPr>
+          <p:cNvPr id="9" name="TextBox 8"/>
+          <p:cNvSpPr txBox="1"/>
+          <p:nvPr/>
+        </p:nvSpPr>
+        <p:spPr>
+          <a:xfrm>
+            <a:off x="5212080" y="2651760"/>
+            <a:ext cx="3657600" cy="822960"/>
+          </a:xfrm>
+          <a:prstGeom prst="rect">
+            <a:avLst/>
+          </a:prstGeom>
+          <a:noFill/>
+        </p:spPr>
+        <p:txBody>
+          <a:bodyPr wrap="square">
+            <a:spAutoFit/>
+          </a:bodyPr>
+          <a:lstStyle/>
+          <a:p>
+            <a:pPr algn="l">
+              <a:defRPr sz="2200" b="1">
+                <a:solidFill>
+                  <a:srgbClr val="00D4AA"/>
+                </a:solidFill>
+              </a:defRPr>
+            </a:pPr>
+            <a:r>
+              <a:t>Session history</a:t>
+            </a:r>
+          </a:p>
+        </p:txBody>
+      </p:sp>
+      <p:sp>
+        <p:nvSpPr>
+          <p:cNvPr id="10" name="TextBox 9"/>
+          <p:cNvSpPr txBox="1"/>
+          <p:nvPr/>
+        </p:nvSpPr>
+        <p:spPr>
+          <a:xfrm>
+            <a:off x="914400" y="3474720"/>
+            <a:ext cx="3200400" cy="822960"/>
+          </a:xfrm>
+          <a:prstGeom prst="rect">
+            <a:avLst/>
+          </a:prstGeom>
+          <a:noFill/>
+        </p:spPr>
+        <p:txBody>
+          <a:bodyPr wrap="square">
+            <a:spAutoFit/>
+          </a:bodyPr>
+          <a:lstStyle/>
+          <a:p>
+            <a:pPr algn="r">
+              <a:defRPr sz="2200" b="1">
+                <a:solidFill>
+                  <a:srgbClr val="FF6B6B"/>
+                </a:solidFill>
+              </a:defRPr>
+            </a:pPr>
+            <a:r>
+              <a:t>Long-term memory</a:t>
+            </a:r>
+          </a:p>
+        </p:txBody>
+      </p:sp>
+      <p:sp>
+        <p:nvSpPr>
+          <p:cNvPr id="11" name="TextBox 10"/>
+          <p:cNvSpPr txBox="1"/>
+          <p:nvPr/>
+        </p:nvSpPr>
+        <p:spPr>
+          <a:xfrm>
+            <a:off x="4297680" y="3474720"/>
+            <a:ext cx="731520" cy="822960"/>
+          </a:xfrm>
+          <a:prstGeom prst="rect">
+            <a:avLst/>
+          </a:prstGeom>
+          <a:noFill/>
+        </p:spPr>
+        <p:txBody>
+          <a:bodyPr wrap="none">
+            <a:spAutoFit/>
+          </a:bodyPr>
+          <a:lstStyle/>
+          <a:p>
+            <a:pPr algn="ctr">
+              <a:defRPr sz="2800">
+                <a:solidFill>
+                  <a:srgbClr val="8A8F98"/>
+                </a:solidFill>
+              </a:defRPr>
+            </a:pPr>
+            <a:r>
+              <a:t>→</a:t>
+            </a:r>
+          </a:p>
+        </p:txBody>
+      </p:sp>
+      <p:sp>
+        <p:nvSpPr>
+          <p:cNvPr id="12" name="TextBox 11"/>
+          <p:cNvSpPr txBox="1"/>
+          <p:nvPr/>
+        </p:nvSpPr>
+        <p:spPr>
+          <a:xfrm>
+            <a:off x="5212080" y="3474720"/>
+            <a:ext cx="3657600" cy="822960"/>
+          </a:xfrm>
+          <a:prstGeom prst="rect">
+            <a:avLst/>
+          </a:prstGeom>
+          <a:noFill/>
+        </p:spPr>
+        <p:txBody>
+          <a:bodyPr wrap="square">
+            <a:spAutoFit/>
+          </a:bodyPr>
+          <a:lstStyle/>
+          <a:p>
+            <a:pPr algn="l">
+              <a:defRPr sz="2200" b="1">
+                <a:solidFill>
+                  <a:srgbClr val="00D4AA"/>
+                </a:solidFill>
+              </a:defRPr>
+            </a:pPr>
+            <a:r>
+              <a:t>CLAUDE.md</a:t>
+            </a:r>
+          </a:p>
+        </p:txBody>
+      </p:sp>
+      <p:sp>
+        <p:nvSpPr>
+          <p:cNvPr id="13" name="TextBox 12"/>
+          <p:cNvSpPr txBox="1"/>
+          <p:nvPr/>
+        </p:nvSpPr>
+        <p:spPr>
+          <a:xfrm>
+            <a:off x="914400" y="4297680"/>
+            <a:ext cx="3200400" cy="822960"/>
+          </a:xfrm>
+          <a:prstGeom prst="rect">
+            <a:avLst/>
+          </a:prstGeom>
+          <a:noFill/>
+        </p:spPr>
+        <p:txBody>
+          <a:bodyPr wrap="square">
+            <a:spAutoFit/>
+          </a:bodyPr>
+          <a:lstStyle/>
+          <a:p>
+            <a:pPr algn="r">
+              <a:defRPr sz="2200" b="1">
+                <a:solidFill>
+                  <a:srgbClr val="FF6B6B"/>
+                </a:solidFill>
+              </a:defRPr>
+            </a:pPr>
+            <a:r>
+              <a:t>Muscle memory</a:t>
+            </a:r>
+          </a:p>
+        </p:txBody>
+      </p:sp>
+      <p:sp>
+        <p:nvSpPr>
+          <p:cNvPr id="14" name="TextBox 13"/>
+          <p:cNvSpPr txBox="1"/>
+          <p:nvPr/>
+        </p:nvSpPr>
+        <p:spPr>
+          <a:xfrm>
+            <a:off x="4297680" y="4297680"/>
+            <a:ext cx="731520" cy="822960"/>
+          </a:xfrm>
+          <a:prstGeom prst="rect">
+            <a:avLst/>
+          </a:prstGeom>
+          <a:noFill/>
+        </p:spPr>
+        <p:txBody>
+          <a:bodyPr wrap="none">
+            <a:spAutoFit/>
+          </a:bodyPr>
+          <a:lstStyle/>
+          <a:p>
+            <a:pPr algn="ctr">
+              <a:defRPr sz="2800">
+                <a:solidFill>
+                  <a:srgbClr val="8A8F98"/>
+                </a:solidFill>
+              </a:defRPr>
+            </a:pPr>
+            <a:r>
+              <a:t>→</a:t>
+            </a:r>
+          </a:p>
+        </p:txBody>
+      </p:sp>
+      <p:sp>
+        <p:nvSpPr>
+          <p:cNvPr id="15" name="TextBox 14"/>
+          <p:cNvSpPr txBox="1"/>
+          <p:nvPr/>
+        </p:nvSpPr>
+        <p:spPr>
+          <a:xfrm>
+            <a:off x="5212080" y="4297680"/>
+            <a:ext cx="3657600" cy="822960"/>
+          </a:xfrm>
+          <a:prstGeom prst="rect">
+            <a:avLst/>
+          </a:prstGeom>
+          <a:noFill/>
+        </p:spPr>
+        <p:txBody>
+          <a:bodyPr wrap="square">
+            <a:spAutoFit/>
+          </a:bodyPr>
+          <a:lstStyle/>
+          <a:p>
+            <a:pPr algn="l">
+              <a:defRPr sz="2200" b="1">
+                <a:solidFill>
+                  <a:srgbClr val="00D4AA"/>
+                </a:solidFill>
+              </a:defRPr>
+            </a:pPr>
+            <a:r>
+              <a:t>Skills &amp; commands</a:t>
+            </a:r>
+          </a:p>
+        </p:txBody>
+      </p:sp>
+      <p:sp>
+        <p:nvSpPr>
+          <p:cNvPr id="16" name="TextBox 15"/>
+          <p:cNvSpPr txBox="1"/>
+          <p:nvPr/>
+        </p:nvSpPr>
+        <p:spPr>
+          <a:xfrm>
+            <a:off x="1371600" y="5303520"/>
+            <a:ext cx="8229600" cy="548640"/>
+          </a:xfrm>
+          <a:prstGeom prst="rect">
+            <a:avLst/>
+          </a:prstGeom>
+          <a:noFill/>
+        </p:spPr>
+        <p:txBody>
+          <a:bodyPr wrap="square">
+            <a:spAutoFit/>
+          </a:bodyPr>
+          <a:lstStyle/>
+          <a:p>
+            <a:pPr algn="ctr">
+              <a:defRPr sz="1600">
+                <a:solidFill>
+                  <a:srgbClr val="8A8F98"/>
+                </a:solidFill>
+              </a:defRPr>
+            </a:pPr>
+            <a:r>
+              <a:t>Everything today teaches you how to manage these four memory layers.</a:t>
             </a:r>
           </a:p>
         </p:txBody>

</xml_diff>

<commit_message>
fix: slide 4 — update What We'll Build Today to match Business Dashboard lab
</commit_message>
<xml_diff>
--- a/slides/Day2_Claude_Code_Fundamentals.pptx
+++ b/slides/Day2_Claude_Code_Fundamentals.pptx
@@ -255,7 +255,7 @@
   <pc:docChgLst>
     <pc:chgData name="Scott Hay" userId="e95d3f44-f6c0-414c-b281-41a9346c1b81" providerId="ADAL" clId="{4D76341F-F64C-4A8E-A4EF-1A11730F38E9}"/>
     <pc:docChg chg="undo custSel modSld">
-      <pc:chgData name="Scott Hay" userId="e95d3f44-f6c0-414c-b281-41a9346c1b81" providerId="ADAL" clId="{4D76341F-F64C-4A8E-A4EF-1A11730F38E9}" dt="2026-03-02T01:49:32.898" v="82" actId="108"/>
+      <pc:chgData name="Scott Hay" userId="e95d3f44-f6c0-414c-b281-41a9346c1b81" providerId="ADAL" clId="{4D76341F-F64C-4A8E-A4EF-1A11730F38E9}" dt="2026-03-02T01:59:12.747" v="87" actId="14100"/>
       <pc:docMkLst>
         <pc:docMk/>
       </pc:docMkLst>
@@ -290,7 +290,7 @@
         </pc:spChg>
       </pc:sldChg>
       <pc:sldChg chg="modSp mod">
-        <pc:chgData name="Scott Hay" userId="e95d3f44-f6c0-414c-b281-41a9346c1b81" providerId="ADAL" clId="{4D76341F-F64C-4A8E-A4EF-1A11730F38E9}" dt="2026-03-02T01:49:32.898" v="82" actId="108"/>
+        <pc:chgData name="Scott Hay" userId="e95d3f44-f6c0-414c-b281-41a9346c1b81" providerId="ADAL" clId="{4D76341F-F64C-4A8E-A4EF-1A11730F38E9}" dt="2026-03-02T01:59:12.747" v="87" actId="14100"/>
         <pc:sldMkLst>
           <pc:docMk/>
           <pc:sldMk cId="0" sldId="265"/>
@@ -304,7 +304,7 @@
           </ac:spMkLst>
         </pc:spChg>
         <pc:spChg chg="mod">
-          <ac:chgData name="Scott Hay" userId="e95d3f44-f6c0-414c-b281-41a9346c1b81" providerId="ADAL" clId="{4D76341F-F64C-4A8E-A4EF-1A11730F38E9}" dt="2026-03-02T01:48:51.608" v="65" actId="14100"/>
+          <ac:chgData name="Scott Hay" userId="e95d3f44-f6c0-414c-b281-41a9346c1b81" providerId="ADAL" clId="{4D76341F-F64C-4A8E-A4EF-1A11730F38E9}" dt="2026-03-02T01:59:12.747" v="87" actId="14100"/>
           <ac:spMkLst>
             <pc:docMk/>
             <pc:sldMk cId="0" sldId="265"/>
@@ -312,7 +312,7 @@
           </ac:spMkLst>
         </pc:spChg>
         <pc:spChg chg="mod">
-          <ac:chgData name="Scott Hay" userId="e95d3f44-f6c0-414c-b281-41a9346c1b81" providerId="ADAL" clId="{4D76341F-F64C-4A8E-A4EF-1A11730F38E9}" dt="2026-03-02T01:49:32.898" v="82" actId="108"/>
+          <ac:chgData name="Scott Hay" userId="e95d3f44-f6c0-414c-b281-41a9346c1b81" providerId="ADAL" clId="{4D76341F-F64C-4A8E-A4EF-1A11730F38E9}" dt="2026-03-02T01:58:50.425" v="85" actId="14100"/>
           <ac:spMkLst>
             <pc:docMk/>
             <pc:sldMk cId="0" sldId="265"/>
@@ -20614,7 +20614,7 @@
         <p:spPr>
           <a:xfrm>
             <a:off x="7604607" y="2011680"/>
-            <a:ext cx="2970628" cy="4846320"/>
+            <a:ext cx="2286001" cy="3200400"/>
           </a:xfrm>
           <a:prstGeom prst="roundRect">
             <a:avLst/>
@@ -20739,7 +20739,7 @@
         <p:spPr>
           <a:xfrm>
             <a:off x="7696047" y="3657600"/>
-            <a:ext cx="2879188" cy="1371600"/>
+            <a:ext cx="2194866" cy="1371600"/>
           </a:xfrm>
           <a:prstGeom prst="rect">
             <a:avLst/>
@@ -20761,6 +20761,7 @@
               </a:defRPr>
             </a:pPr>
             <a:r>
+              <a:rPr dirty="0"/>
               <a:t>Account</a:t>
             </a:r>
           </a:p>
@@ -20776,6 +20777,7 @@
               </a:defRPr>
             </a:pPr>
             <a:r>
+              <a:rPr dirty="0"/>
               <a:t>Anthropic Pro or Max plan</a:t>
             </a:r>
           </a:p>
@@ -20791,6 +20793,7 @@
               </a:defRPr>
             </a:pPr>
             <a:r>
+              <a:rPr dirty="0"/>
               <a:t>Install: claude.ai/install.sh</a:t>
             </a:r>
           </a:p>
@@ -20806,7 +20809,16 @@
               </a:defRPr>
             </a:pPr>
             <a:r>
-              <a:t>Authenticate: claude login</a:t>
+              <a:rPr dirty="0"/>
+              <a:t>Authenticate: </a:t>
+            </a:r>
+            <a:r>
+              <a:rPr dirty="0" err="1"/>
+              <a:t>claude</a:t>
+            </a:r>
+            <a:r>
+              <a:rPr dirty="0"/>
+              <a:t> login</a:t>
             </a:r>
           </a:p>
         </p:txBody>
@@ -41719,43 +41731,8 @@
         </p:nvSpPr>
         <p:spPr>
           <a:xfrm>
-            <a:off x="457200" y="1371600"/>
-            <a:ext cx="411480" cy="411480"/>
-          </a:xfrm>
-          <a:prstGeom prst="rect">
-            <a:avLst/>
-          </a:prstGeom>
-          <a:noFill/>
-        </p:spPr>
-        <p:txBody>
-          <a:bodyPr wrap="none" anchor="ctr">
-            <a:spAutoFit/>
-          </a:bodyPr>
-          <a:lstStyle/>
-          <a:p>
-            <a:pPr algn="ctr">
-              <a:defRPr sz="2000" b="1">
-                <a:solidFill>
-                  <a:srgbClr val="0B0F1A"/>
-                </a:solidFill>
-              </a:defRPr>
-            </a:pPr>
-            <a:r>
-              <a:t>v</a:t>
-            </a:r>
-          </a:p>
-        </p:txBody>
-      </p:sp>
-      <p:sp>
-        <p:nvSpPr>
-          <p:cNvPr id="6" name="TextBox 5"/>
-          <p:cNvSpPr txBox="1"/>
-          <p:nvPr/>
-        </p:nvSpPr>
-        <p:spPr>
-          <a:xfrm>
-            <a:off x="1005840" y="1417320"/>
-            <a:ext cx="10728655" cy="731520"/>
+            <a:off x="731520" y="1828800"/>
+            <a:ext cx="1645920" cy="365760"/>
           </a:xfrm>
           <a:prstGeom prst="rect">
             <a:avLst/>
@@ -41769,107 +41746,28 @@
           <a:lstStyle/>
           <a:p>
             <a:pPr>
-              <a:defRPr sz="2200">
-                <a:solidFill>
-                  <a:srgbClr val="FFFFFF"/>
-                </a:solidFill>
-              </a:defRPr>
-            </a:pPr>
-            <a:r>
-              <a:t>Lab 1: Debug a real authentication bug, write comprehensive tests, generate documentation</a:t>
-            </a:r>
-          </a:p>
-        </p:txBody>
-      </p:sp>
-      <p:sp>
-        <p:nvSpPr>
-          <p:cNvPr id="7" name="Oval 6"/>
-          <p:cNvSpPr/>
-          <p:nvPr/>
-        </p:nvSpPr>
-        <p:spPr>
-          <a:xfrm>
-            <a:off x="457200" y="2194560"/>
-            <a:ext cx="411480" cy="411480"/>
-          </a:xfrm>
-          <a:prstGeom prst="ellipse">
-            <a:avLst/>
-          </a:prstGeom>
-          <a:solidFill>
-            <a:srgbClr val="00D4AA"/>
-          </a:solidFill>
-          <a:ln>
-            <a:noFill/>
-          </a:ln>
-        </p:spPr>
-        <p:style>
-          <a:lnRef idx="1">
-            <a:schemeClr val="accent1"/>
-          </a:lnRef>
-          <a:fillRef idx="3">
-            <a:schemeClr val="accent1"/>
-          </a:fillRef>
-          <a:effectRef idx="2">
-            <a:schemeClr val="accent1"/>
-          </a:effectRef>
-          <a:fontRef idx="minor">
-            <a:schemeClr val="lt1"/>
-          </a:fontRef>
-        </p:style>
-        <p:txBody>
-          <a:bodyPr rtlCol="0" anchor="ctr"/>
-          <a:lstStyle/>
-          <a:p>
-            <a:pPr algn="ctr"/>
-            <a:endParaRPr/>
-          </a:p>
-        </p:txBody>
-      </p:sp>
-      <p:sp>
-        <p:nvSpPr>
-          <p:cNvPr id="8" name="TextBox 7"/>
+              <a:defRPr sz="1800" b="1">
+                <a:solidFill>
+                  <a:srgbClr val="00D4AA"/>
+                </a:solidFill>
+              </a:defRPr>
+            </a:pPr>
+            <a:r>
+              <a:t>Exercise 1:</a:t>
+            </a:r>
+          </a:p>
+        </p:txBody>
+      </p:sp>
+      <p:sp>
+        <p:nvSpPr>
+          <p:cNvPr id="6" name="TextBox 5"/>
           <p:cNvSpPr txBox="1"/>
           <p:nvPr/>
         </p:nvSpPr>
         <p:spPr>
           <a:xfrm>
-            <a:off x="457200" y="2194560"/>
-            <a:ext cx="411480" cy="411480"/>
-          </a:xfrm>
-          <a:prstGeom prst="rect">
-            <a:avLst/>
-          </a:prstGeom>
-          <a:noFill/>
-        </p:spPr>
-        <p:txBody>
-          <a:bodyPr wrap="none" anchor="ctr">
-            <a:spAutoFit/>
-          </a:bodyPr>
-          <a:lstStyle/>
-          <a:p>
-            <a:pPr algn="ctr">
-              <a:defRPr sz="2000" b="1">
-                <a:solidFill>
-                  <a:srgbClr val="0B0F1A"/>
-                </a:solidFill>
-              </a:defRPr>
-            </a:pPr>
-            <a:r>
-              <a:t>v</a:t>
-            </a:r>
-          </a:p>
-        </p:txBody>
-      </p:sp>
-      <p:sp>
-        <p:nvSpPr>
-          <p:cNvPr id="9" name="TextBox 8"/>
-          <p:cNvSpPr txBox="1"/>
-          <p:nvPr/>
-        </p:nvSpPr>
-        <p:spPr>
-          <a:xfrm>
-            <a:off x="1005840" y="2240280"/>
-            <a:ext cx="10728655" cy="731520"/>
+            <a:off x="2468880" y="1828800"/>
+            <a:ext cx="7772400" cy="640080"/>
           </a:xfrm>
           <a:prstGeom prst="rect">
             <a:avLst/>
@@ -41883,107 +41781,28 @@
           <a:lstStyle/>
           <a:p>
             <a:pPr>
-              <a:defRPr sz="2200">
-                <a:solidFill>
-                  <a:srgbClr val="FFFFFF"/>
-                </a:solidFill>
-              </a:defRPr>
-            </a:pPr>
-            <a:r>
-              <a:t>Lab 2: Refactor a legacy module, create feature branch, generate semantic commits, and submit a PR</a:t>
-            </a:r>
-          </a:p>
-        </p:txBody>
-      </p:sp>
-      <p:sp>
-        <p:nvSpPr>
-          <p:cNvPr id="10" name="Oval 9"/>
-          <p:cNvSpPr/>
-          <p:nvPr/>
-        </p:nvSpPr>
-        <p:spPr>
-          <a:xfrm>
-            <a:off x="457200" y="3017520"/>
-            <a:ext cx="411480" cy="411480"/>
-          </a:xfrm>
-          <a:prstGeom prst="ellipse">
-            <a:avLst/>
-          </a:prstGeom>
-          <a:solidFill>
-            <a:srgbClr val="00D4AA"/>
-          </a:solidFill>
-          <a:ln>
-            <a:noFill/>
-          </a:ln>
-        </p:spPr>
-        <p:style>
-          <a:lnRef idx="1">
-            <a:schemeClr val="accent1"/>
-          </a:lnRef>
-          <a:fillRef idx="3">
-            <a:schemeClr val="accent1"/>
-          </a:fillRef>
-          <a:effectRef idx="2">
-            <a:schemeClr val="accent1"/>
-          </a:effectRef>
-          <a:fontRef idx="minor">
-            <a:schemeClr val="lt1"/>
-          </a:fontRef>
-        </p:style>
-        <p:txBody>
-          <a:bodyPr rtlCol="0" anchor="ctr"/>
-          <a:lstStyle/>
-          <a:p>
-            <a:pPr algn="ctr"/>
-            <a:endParaRPr/>
-          </a:p>
-        </p:txBody>
-      </p:sp>
-      <p:sp>
-        <p:nvSpPr>
-          <p:cNvPr id="11" name="TextBox 10"/>
+              <a:defRPr sz="1600">
+                <a:solidFill>
+                  <a:srgbClr val="FFFFFF"/>
+                </a:solidFill>
+              </a:defRPr>
+            </a:pPr>
+            <a:r>
+              <a:t>Build a complete Business Dashboard from a single prompt — API, database, and UI</a:t>
+            </a:r>
+          </a:p>
+        </p:txBody>
+      </p:sp>
+      <p:sp>
+        <p:nvSpPr>
+          <p:cNvPr id="7" name="TextBox 6"/>
           <p:cNvSpPr txBox="1"/>
           <p:nvPr/>
         </p:nvSpPr>
         <p:spPr>
           <a:xfrm>
-            <a:off x="457200" y="3017520"/>
-            <a:ext cx="411480" cy="411480"/>
-          </a:xfrm>
-          <a:prstGeom prst="rect">
-            <a:avLst/>
-          </a:prstGeom>
-          <a:noFill/>
-        </p:spPr>
-        <p:txBody>
-          <a:bodyPr wrap="none" anchor="ctr">
-            <a:spAutoFit/>
-          </a:bodyPr>
-          <a:lstStyle/>
-          <a:p>
-            <a:pPr algn="ctr">
-              <a:defRPr sz="2000" b="1">
-                <a:solidFill>
-                  <a:srgbClr val="0B0F1A"/>
-                </a:solidFill>
-              </a:defRPr>
-            </a:pPr>
-            <a:r>
-              <a:t>v</a:t>
-            </a:r>
-          </a:p>
-        </p:txBody>
-      </p:sp>
-      <p:sp>
-        <p:nvSpPr>
-          <p:cNvPr id="12" name="TextBox 11"/>
-          <p:cNvSpPr txBox="1"/>
-          <p:nvPr/>
-        </p:nvSpPr>
-        <p:spPr>
-          <a:xfrm>
-            <a:off x="1005840" y="3063240"/>
-            <a:ext cx="10728655" cy="731520"/>
+            <a:off x="731520" y="2606040"/>
+            <a:ext cx="1645920" cy="365760"/>
           </a:xfrm>
           <a:prstGeom prst="rect">
             <a:avLst/>
@@ -41997,107 +41816,28 @@
           <a:lstStyle/>
           <a:p>
             <a:pPr>
-              <a:defRPr sz="2200">
-                <a:solidFill>
-                  <a:srgbClr val="FFFFFF"/>
-                </a:solidFill>
-              </a:defRPr>
-            </a:pPr>
-            <a:r>
-              <a:t>Bonus: Custom CLAUDE.md for your team's coding standards</a:t>
-            </a:r>
-          </a:p>
-        </p:txBody>
-      </p:sp>
-      <p:sp>
-        <p:nvSpPr>
-          <p:cNvPr id="13" name="Oval 12"/>
-          <p:cNvSpPr/>
-          <p:nvPr/>
-        </p:nvSpPr>
-        <p:spPr>
-          <a:xfrm>
-            <a:off x="457200" y="3840480"/>
-            <a:ext cx="411480" cy="411480"/>
-          </a:xfrm>
-          <a:prstGeom prst="ellipse">
-            <a:avLst/>
-          </a:prstGeom>
-          <a:solidFill>
-            <a:srgbClr val="00D4AA"/>
-          </a:solidFill>
-          <a:ln>
-            <a:noFill/>
-          </a:ln>
-        </p:spPr>
-        <p:style>
-          <a:lnRef idx="1">
-            <a:schemeClr val="accent1"/>
-          </a:lnRef>
-          <a:fillRef idx="3">
-            <a:schemeClr val="accent1"/>
-          </a:fillRef>
-          <a:effectRef idx="2">
-            <a:schemeClr val="accent1"/>
-          </a:effectRef>
-          <a:fontRef idx="minor">
-            <a:schemeClr val="lt1"/>
-          </a:fontRef>
-        </p:style>
-        <p:txBody>
-          <a:bodyPr rtlCol="0" anchor="ctr"/>
-          <a:lstStyle/>
-          <a:p>
-            <a:pPr algn="ctr"/>
-            <a:endParaRPr/>
-          </a:p>
-        </p:txBody>
-      </p:sp>
-      <p:sp>
-        <p:nvSpPr>
-          <p:cNvPr id="14" name="TextBox 13"/>
+              <a:defRPr sz="1800" b="1">
+                <a:solidFill>
+                  <a:srgbClr val="00D4AA"/>
+                </a:solidFill>
+              </a:defRPr>
+            </a:pPr>
+            <a:r>
+              <a:t>Exercise 2:</a:t>
+            </a:r>
+          </a:p>
+        </p:txBody>
+      </p:sp>
+      <p:sp>
+        <p:nvSpPr>
+          <p:cNvPr id="8" name="TextBox 7"/>
           <p:cNvSpPr txBox="1"/>
           <p:nvPr/>
         </p:nvSpPr>
         <p:spPr>
           <a:xfrm>
-            <a:off x="457200" y="3840480"/>
-            <a:ext cx="411480" cy="411480"/>
-          </a:xfrm>
-          <a:prstGeom prst="rect">
-            <a:avLst/>
-          </a:prstGeom>
-          <a:noFill/>
-        </p:spPr>
-        <p:txBody>
-          <a:bodyPr wrap="none" anchor="ctr">
-            <a:spAutoFit/>
-          </a:bodyPr>
-          <a:lstStyle/>
-          <a:p>
-            <a:pPr algn="ctr">
-              <a:defRPr sz="2000" b="1">
-                <a:solidFill>
-                  <a:srgbClr val="0B0F1A"/>
-                </a:solidFill>
-              </a:defRPr>
-            </a:pPr>
-            <a:r>
-              <a:t>v</a:t>
-            </a:r>
-          </a:p>
-        </p:txBody>
-      </p:sp>
-      <p:sp>
-        <p:nvSpPr>
-          <p:cNvPr id="15" name="TextBox 14"/>
-          <p:cNvSpPr txBox="1"/>
-          <p:nvPr/>
-        </p:nvSpPr>
-        <p:spPr>
-          <a:xfrm>
-            <a:off x="1005840" y="3886200"/>
-            <a:ext cx="10728655" cy="731520"/>
+            <a:off x="2468880" y="2606040"/>
+            <a:ext cx="7772400" cy="640080"/>
           </a:xfrm>
           <a:prstGeom prst="rect">
             <a:avLst/>
@@ -42111,14 +41851,224 @@
           <a:lstStyle/>
           <a:p>
             <a:pPr>
-              <a:defRPr sz="2200">
-                <a:solidFill>
-                  <a:srgbClr val="FFFFFF"/>
-                </a:solidFill>
-              </a:defRPr>
-            </a:pPr>
-            <a:r>
-              <a:t>Bonus: .claudeignore patterns optimized for your stack</a:t>
+              <a:defRPr sz="1600">
+                <a:solidFill>
+                  <a:srgbClr val="FFFFFF"/>
+                </a:solidFill>
+              </a:defRPr>
+            </a:pPr>
+            <a:r>
+              <a:t>Add a project brain with CLAUDE.md — conventions that enforce themselves</a:t>
+            </a:r>
+          </a:p>
+        </p:txBody>
+      </p:sp>
+      <p:sp>
+        <p:nvSpPr>
+          <p:cNvPr id="9" name="TextBox 8"/>
+          <p:cNvSpPr txBox="1"/>
+          <p:nvPr/>
+        </p:nvSpPr>
+        <p:spPr>
+          <a:xfrm>
+            <a:off x="731520" y="3383280"/>
+            <a:ext cx="1645920" cy="365760"/>
+          </a:xfrm>
+          <a:prstGeom prst="rect">
+            <a:avLst/>
+          </a:prstGeom>
+          <a:noFill/>
+        </p:spPr>
+        <p:txBody>
+          <a:bodyPr wrap="square">
+            <a:spAutoFit/>
+          </a:bodyPr>
+          <a:lstStyle/>
+          <a:p>
+            <a:pPr>
+              <a:defRPr sz="1800" b="1">
+                <a:solidFill>
+                  <a:srgbClr val="00D4AA"/>
+                </a:solidFill>
+              </a:defRPr>
+            </a:pPr>
+            <a:r>
+              <a:t>Exercise 3:</a:t>
+            </a:r>
+          </a:p>
+        </p:txBody>
+      </p:sp>
+      <p:sp>
+        <p:nvSpPr>
+          <p:cNvPr id="10" name="TextBox 9"/>
+          <p:cNvSpPr txBox="1"/>
+          <p:nvPr/>
+        </p:nvSpPr>
+        <p:spPr>
+          <a:xfrm>
+            <a:off x="2468880" y="3383280"/>
+            <a:ext cx="7772400" cy="640080"/>
+          </a:xfrm>
+          <a:prstGeom prst="rect">
+            <a:avLst/>
+          </a:prstGeom>
+          <a:noFill/>
+        </p:spPr>
+        <p:txBody>
+          <a:bodyPr wrap="square">
+            <a:spAutoFit/>
+          </a:bodyPr>
+          <a:lstStyle/>
+          <a:p>
+            <a:pPr>
+              <a:defRPr sz="1600">
+                <a:solidFill>
+                  <a:srgbClr val="FFFFFF"/>
+                </a:solidFill>
+              </a:defRPr>
+            </a:pPr>
+            <a:r>
+              <a:t>Master @ mentions for precision context, plus break-and-recover workflows</a:t>
+            </a:r>
+          </a:p>
+        </p:txBody>
+      </p:sp>
+      <p:sp>
+        <p:nvSpPr>
+          <p:cNvPr id="11" name="TextBox 10"/>
+          <p:cNvSpPr txBox="1"/>
+          <p:nvPr/>
+        </p:nvSpPr>
+        <p:spPr>
+          <a:xfrm>
+            <a:off x="731520" y="4160520"/>
+            <a:ext cx="1645920" cy="365760"/>
+          </a:xfrm>
+          <a:prstGeom prst="rect">
+            <a:avLst/>
+          </a:prstGeom>
+          <a:noFill/>
+        </p:spPr>
+        <p:txBody>
+          <a:bodyPr wrap="square">
+            <a:spAutoFit/>
+          </a:bodyPr>
+          <a:lstStyle/>
+          <a:p>
+            <a:pPr>
+              <a:defRPr sz="1800" b="1">
+                <a:solidFill>
+                  <a:srgbClr val="00D4AA"/>
+                </a:solidFill>
+              </a:defRPr>
+            </a:pPr>
+            <a:r>
+              <a:t>Exercise 4:</a:t>
+            </a:r>
+          </a:p>
+        </p:txBody>
+      </p:sp>
+      <p:sp>
+        <p:nvSpPr>
+          <p:cNvPr id="12" name="TextBox 11"/>
+          <p:cNvSpPr txBox="1"/>
+          <p:nvPr/>
+        </p:nvSpPr>
+        <p:spPr>
+          <a:xfrm>
+            <a:off x="2468880" y="4160520"/>
+            <a:ext cx="7772400" cy="640080"/>
+          </a:xfrm>
+          <a:prstGeom prst="rect">
+            <a:avLst/>
+          </a:prstGeom>
+          <a:noFill/>
+        </p:spPr>
+        <p:txBody>
+          <a:bodyPr wrap="square">
+            <a:spAutoFit/>
+          </a:bodyPr>
+          <a:lstStyle/>
+          <a:p>
+            <a:pPr>
+              <a:defRPr sz="1600">
+                <a:solidFill>
+                  <a:srgbClr val="FFFFFF"/>
+                </a:solidFill>
+              </a:defRPr>
+            </a:pPr>
+            <a:r>
+              <a:t>Iterate to great — charts, filters, production hardening</a:t>
+            </a:r>
+          </a:p>
+        </p:txBody>
+      </p:sp>
+      <p:sp>
+        <p:nvSpPr>
+          <p:cNvPr id="13" name="TextBox 12"/>
+          <p:cNvSpPr txBox="1"/>
+          <p:nvPr/>
+        </p:nvSpPr>
+        <p:spPr>
+          <a:xfrm>
+            <a:off x="731520" y="4937760"/>
+            <a:ext cx="1645920" cy="365760"/>
+          </a:xfrm>
+          <a:prstGeom prst="rect">
+            <a:avLst/>
+          </a:prstGeom>
+          <a:noFill/>
+        </p:spPr>
+        <p:txBody>
+          <a:bodyPr wrap="square">
+            <a:spAutoFit/>
+          </a:bodyPr>
+          <a:lstStyle/>
+          <a:p>
+            <a:pPr>
+              <a:defRPr sz="1800" b="1">
+                <a:solidFill>
+                  <a:srgbClr val="00D4AA"/>
+                </a:solidFill>
+              </a:defRPr>
+            </a:pPr>
+            <a:r>
+              <a:t>Exercise 5:</a:t>
+            </a:r>
+          </a:p>
+        </p:txBody>
+      </p:sp>
+      <p:sp>
+        <p:nvSpPr>
+          <p:cNvPr id="14" name="TextBox 13"/>
+          <p:cNvSpPr txBox="1"/>
+          <p:nvPr/>
+        </p:nvSpPr>
+        <p:spPr>
+          <a:xfrm>
+            <a:off x="2468880" y="4937760"/>
+            <a:ext cx="7772400" cy="640080"/>
+          </a:xfrm>
+          <a:prstGeom prst="rect">
+            <a:avLst/>
+          </a:prstGeom>
+          <a:noFill/>
+        </p:spPr>
+        <p:txBody>
+          <a:bodyPr wrap="square">
+            <a:spAutoFit/>
+          </a:bodyPr>
+          <a:lstStyle/>
+          <a:p>
+            <a:pPr>
+              <a:defRPr sz="1600">
+                <a:solidFill>
+                  <a:srgbClr val="FFFFFF"/>
+                </a:solidFill>
+              </a:defRPr>
+            </a:pPr>
+            <a:r>
+              <a:t>Git workflow in natural language — branches, commits, and merges</a:t>
             </a:r>
           </a:p>
         </p:txBody>
@@ -57124,6 +57074,426 @@
       <p:sp>
         <p:nvSpPr>
           <p:cNvPr id="16" name="TextBox 15"/>
+          <p:cNvSpPr txBox="1"/>
+          <p:nvPr/>
+        </p:nvSpPr>
+        <p:spPr>
+          <a:xfrm>
+            <a:off x="1371600" y="5303520"/>
+            <a:ext cx="8229600" cy="548640"/>
+          </a:xfrm>
+          <a:prstGeom prst="rect">
+            <a:avLst/>
+          </a:prstGeom>
+          <a:noFill/>
+        </p:spPr>
+        <p:txBody>
+          <a:bodyPr wrap="square">
+            <a:spAutoFit/>
+          </a:bodyPr>
+          <a:lstStyle/>
+          <a:p>
+            <a:pPr algn="ctr">
+              <a:defRPr sz="1600">
+                <a:solidFill>
+                  <a:srgbClr val="8A8F98"/>
+                </a:solidFill>
+              </a:defRPr>
+            </a:pPr>
+            <a:r>
+              <a:t>Everything today teaches you how to manage these four memory layers.</a:t>
+            </a:r>
+          </a:p>
+        </p:txBody>
+      </p:sp>
+      <p:sp>
+        <p:nvSpPr>
+          <p:cNvPr id="17" name="TextBox 16"/>
+          <p:cNvSpPr txBox="1"/>
+          <p:nvPr/>
+        </p:nvSpPr>
+        <p:spPr>
+          <a:xfrm>
+            <a:off x="4297680" y="1828800"/>
+            <a:ext cx="731520" cy="822960"/>
+          </a:xfrm>
+          <a:prstGeom prst="rect">
+            <a:avLst/>
+          </a:prstGeom>
+          <a:noFill/>
+        </p:spPr>
+        <p:txBody>
+          <a:bodyPr wrap="none">
+            <a:spAutoFit/>
+          </a:bodyPr>
+          <a:lstStyle/>
+          <a:p>
+            <a:pPr algn="ctr">
+              <a:defRPr sz="2800">
+                <a:solidFill>
+                  <a:srgbClr val="8A8F98"/>
+                </a:solidFill>
+              </a:defRPr>
+            </a:pPr>
+            <a:r>
+              <a:t>→</a:t>
+            </a:r>
+          </a:p>
+        </p:txBody>
+      </p:sp>
+      <p:sp>
+        <p:nvSpPr>
+          <p:cNvPr id="18" name="TextBox 17"/>
+          <p:cNvSpPr txBox="1"/>
+          <p:nvPr/>
+        </p:nvSpPr>
+        <p:spPr>
+          <a:xfrm>
+            <a:off x="5212080" y="1828800"/>
+            <a:ext cx="3657600" cy="822960"/>
+          </a:xfrm>
+          <a:prstGeom prst="rect">
+            <a:avLst/>
+          </a:prstGeom>
+          <a:noFill/>
+        </p:spPr>
+        <p:txBody>
+          <a:bodyPr wrap="square">
+            <a:spAutoFit/>
+          </a:bodyPr>
+          <a:lstStyle/>
+          <a:p>
+            <a:pPr algn="l">
+              <a:defRPr sz="2200" b="1">
+                <a:solidFill>
+                  <a:srgbClr val="00D4AA"/>
+                </a:solidFill>
+              </a:defRPr>
+            </a:pPr>
+            <a:r>
+              <a:t>Context window</a:t>
+            </a:r>
+          </a:p>
+        </p:txBody>
+      </p:sp>
+      <p:sp>
+        <p:nvSpPr>
+          <p:cNvPr id="19" name="TextBox 18"/>
+          <p:cNvSpPr txBox="1"/>
+          <p:nvPr/>
+        </p:nvSpPr>
+        <p:spPr>
+          <a:xfrm>
+            <a:off x="914400" y="2651760"/>
+            <a:ext cx="3200400" cy="822960"/>
+          </a:xfrm>
+          <a:prstGeom prst="rect">
+            <a:avLst/>
+          </a:prstGeom>
+          <a:noFill/>
+        </p:spPr>
+        <p:txBody>
+          <a:bodyPr wrap="square">
+            <a:spAutoFit/>
+          </a:bodyPr>
+          <a:lstStyle/>
+          <a:p>
+            <a:pPr algn="r">
+              <a:defRPr sz="2200" b="1">
+                <a:solidFill>
+                  <a:srgbClr val="FF6B6B"/>
+                </a:solidFill>
+              </a:defRPr>
+            </a:pPr>
+            <a:r>
+              <a:t>Short-term memory</a:t>
+            </a:r>
+          </a:p>
+        </p:txBody>
+      </p:sp>
+      <p:sp>
+        <p:nvSpPr>
+          <p:cNvPr id="20" name="TextBox 19"/>
+          <p:cNvSpPr txBox="1"/>
+          <p:nvPr/>
+        </p:nvSpPr>
+        <p:spPr>
+          <a:xfrm>
+            <a:off x="4297680" y="2651760"/>
+            <a:ext cx="731520" cy="822960"/>
+          </a:xfrm>
+          <a:prstGeom prst="rect">
+            <a:avLst/>
+          </a:prstGeom>
+          <a:noFill/>
+        </p:spPr>
+        <p:txBody>
+          <a:bodyPr wrap="none">
+            <a:spAutoFit/>
+          </a:bodyPr>
+          <a:lstStyle/>
+          <a:p>
+            <a:pPr algn="ctr">
+              <a:defRPr sz="2800">
+                <a:solidFill>
+                  <a:srgbClr val="8A8F98"/>
+                </a:solidFill>
+              </a:defRPr>
+            </a:pPr>
+            <a:r>
+              <a:t>→</a:t>
+            </a:r>
+          </a:p>
+        </p:txBody>
+      </p:sp>
+      <p:sp>
+        <p:nvSpPr>
+          <p:cNvPr id="21" name="TextBox 20"/>
+          <p:cNvSpPr txBox="1"/>
+          <p:nvPr/>
+        </p:nvSpPr>
+        <p:spPr>
+          <a:xfrm>
+            <a:off x="5212080" y="2651760"/>
+            <a:ext cx="3657600" cy="822960"/>
+          </a:xfrm>
+          <a:prstGeom prst="rect">
+            <a:avLst/>
+          </a:prstGeom>
+          <a:noFill/>
+        </p:spPr>
+        <p:txBody>
+          <a:bodyPr wrap="square">
+            <a:spAutoFit/>
+          </a:bodyPr>
+          <a:lstStyle/>
+          <a:p>
+            <a:pPr algn="l">
+              <a:defRPr sz="2200" b="1">
+                <a:solidFill>
+                  <a:srgbClr val="00D4AA"/>
+                </a:solidFill>
+              </a:defRPr>
+            </a:pPr>
+            <a:r>
+              <a:t>Session history</a:t>
+            </a:r>
+          </a:p>
+        </p:txBody>
+      </p:sp>
+      <p:sp>
+        <p:nvSpPr>
+          <p:cNvPr id="22" name="TextBox 21"/>
+          <p:cNvSpPr txBox="1"/>
+          <p:nvPr/>
+        </p:nvSpPr>
+        <p:spPr>
+          <a:xfrm>
+            <a:off x="914400" y="3474720"/>
+            <a:ext cx="3200400" cy="822960"/>
+          </a:xfrm>
+          <a:prstGeom prst="rect">
+            <a:avLst/>
+          </a:prstGeom>
+          <a:noFill/>
+        </p:spPr>
+        <p:txBody>
+          <a:bodyPr wrap="square">
+            <a:spAutoFit/>
+          </a:bodyPr>
+          <a:lstStyle/>
+          <a:p>
+            <a:pPr algn="r">
+              <a:defRPr sz="2200" b="1">
+                <a:solidFill>
+                  <a:srgbClr val="FF6B6B"/>
+                </a:solidFill>
+              </a:defRPr>
+            </a:pPr>
+            <a:r>
+              <a:t>Long-term memory</a:t>
+            </a:r>
+          </a:p>
+        </p:txBody>
+      </p:sp>
+      <p:sp>
+        <p:nvSpPr>
+          <p:cNvPr id="23" name="TextBox 22"/>
+          <p:cNvSpPr txBox="1"/>
+          <p:nvPr/>
+        </p:nvSpPr>
+        <p:spPr>
+          <a:xfrm>
+            <a:off x="4297680" y="3474720"/>
+            <a:ext cx="731520" cy="822960"/>
+          </a:xfrm>
+          <a:prstGeom prst="rect">
+            <a:avLst/>
+          </a:prstGeom>
+          <a:noFill/>
+        </p:spPr>
+        <p:txBody>
+          <a:bodyPr wrap="none">
+            <a:spAutoFit/>
+          </a:bodyPr>
+          <a:lstStyle/>
+          <a:p>
+            <a:pPr algn="ctr">
+              <a:defRPr sz="2800">
+                <a:solidFill>
+                  <a:srgbClr val="8A8F98"/>
+                </a:solidFill>
+              </a:defRPr>
+            </a:pPr>
+            <a:r>
+              <a:t>→</a:t>
+            </a:r>
+          </a:p>
+        </p:txBody>
+      </p:sp>
+      <p:sp>
+        <p:nvSpPr>
+          <p:cNvPr id="24" name="TextBox 23"/>
+          <p:cNvSpPr txBox="1"/>
+          <p:nvPr/>
+        </p:nvSpPr>
+        <p:spPr>
+          <a:xfrm>
+            <a:off x="5212080" y="3474720"/>
+            <a:ext cx="3657600" cy="822960"/>
+          </a:xfrm>
+          <a:prstGeom prst="rect">
+            <a:avLst/>
+          </a:prstGeom>
+          <a:noFill/>
+        </p:spPr>
+        <p:txBody>
+          <a:bodyPr wrap="square">
+            <a:spAutoFit/>
+          </a:bodyPr>
+          <a:lstStyle/>
+          <a:p>
+            <a:pPr algn="l">
+              <a:defRPr sz="2200" b="1">
+                <a:solidFill>
+                  <a:srgbClr val="00D4AA"/>
+                </a:solidFill>
+              </a:defRPr>
+            </a:pPr>
+            <a:r>
+              <a:t>CLAUDE.md</a:t>
+            </a:r>
+          </a:p>
+        </p:txBody>
+      </p:sp>
+      <p:sp>
+        <p:nvSpPr>
+          <p:cNvPr id="25" name="TextBox 24"/>
+          <p:cNvSpPr txBox="1"/>
+          <p:nvPr/>
+        </p:nvSpPr>
+        <p:spPr>
+          <a:xfrm>
+            <a:off x="914400" y="4297680"/>
+            <a:ext cx="3200400" cy="822960"/>
+          </a:xfrm>
+          <a:prstGeom prst="rect">
+            <a:avLst/>
+          </a:prstGeom>
+          <a:noFill/>
+        </p:spPr>
+        <p:txBody>
+          <a:bodyPr wrap="square">
+            <a:spAutoFit/>
+          </a:bodyPr>
+          <a:lstStyle/>
+          <a:p>
+            <a:pPr algn="r">
+              <a:defRPr sz="2200" b="1">
+                <a:solidFill>
+                  <a:srgbClr val="FF6B6B"/>
+                </a:solidFill>
+              </a:defRPr>
+            </a:pPr>
+            <a:r>
+              <a:t>Muscle memory</a:t>
+            </a:r>
+          </a:p>
+        </p:txBody>
+      </p:sp>
+      <p:sp>
+        <p:nvSpPr>
+          <p:cNvPr id="26" name="TextBox 25"/>
+          <p:cNvSpPr txBox="1"/>
+          <p:nvPr/>
+        </p:nvSpPr>
+        <p:spPr>
+          <a:xfrm>
+            <a:off x="4297680" y="4297680"/>
+            <a:ext cx="731520" cy="822960"/>
+          </a:xfrm>
+          <a:prstGeom prst="rect">
+            <a:avLst/>
+          </a:prstGeom>
+          <a:noFill/>
+        </p:spPr>
+        <p:txBody>
+          <a:bodyPr wrap="none">
+            <a:spAutoFit/>
+          </a:bodyPr>
+          <a:lstStyle/>
+          <a:p>
+            <a:pPr algn="ctr">
+              <a:defRPr sz="2800">
+                <a:solidFill>
+                  <a:srgbClr val="8A8F98"/>
+                </a:solidFill>
+              </a:defRPr>
+            </a:pPr>
+            <a:r>
+              <a:t>→</a:t>
+            </a:r>
+          </a:p>
+        </p:txBody>
+      </p:sp>
+      <p:sp>
+        <p:nvSpPr>
+          <p:cNvPr id="27" name="TextBox 26"/>
+          <p:cNvSpPr txBox="1"/>
+          <p:nvPr/>
+        </p:nvSpPr>
+        <p:spPr>
+          <a:xfrm>
+            <a:off x="5212080" y="4297680"/>
+            <a:ext cx="3657600" cy="822960"/>
+          </a:xfrm>
+          <a:prstGeom prst="rect">
+            <a:avLst/>
+          </a:prstGeom>
+          <a:noFill/>
+        </p:spPr>
+        <p:txBody>
+          <a:bodyPr wrap="square">
+            <a:spAutoFit/>
+          </a:bodyPr>
+          <a:lstStyle/>
+          <a:p>
+            <a:pPr algn="l">
+              <a:defRPr sz="2200" b="1">
+                <a:solidFill>
+                  <a:srgbClr val="00D4AA"/>
+                </a:solidFill>
+              </a:defRPr>
+            </a:pPr>
+            <a:r>
+              <a:t>Skills &amp; commands</a:t>
+            </a:r>
+          </a:p>
+        </p:txBody>
+      </p:sp>
+      <p:sp>
+        <p:nvSpPr>
+          <p:cNvPr id="28" name="TextBox 27"/>
           <p:cNvSpPr txBox="1"/>
           <p:nvPr/>
         </p:nvSpPr>

</xml_diff>

<commit_message>
docs: add lessons.md compounding loop and staff engineer verification bar to speaker notes
</commit_message>
<xml_diff>
--- a/slides/Day2_Claude_Code_Fundamentals.pptx
+++ b/slides/Day2_Claude_Code_Fundamentals.pptx
@@ -7564,6 +7564,13 @@
               <a:t>   Next topic...</a:t>
             </a:r>
           </a:p>
+          <a:p>
+            <a:br/>
+            <a:br/>
+            <a:r>
+              <a:t>COMPOUNDING FEEDBACK LOOP: Advanced teams add a tasks/lessons.md file that Claude updates after EVERY correction. When Claude makes a mistake and you fix it, tell Claude to record the pattern in lessons.md. Over time, the mistake rate drops because Claude reads its own error log before starting work. Boris Cherny's team at Anthropic uses this internally. The setup takes 10 minutes — add one line to CLAUDE.md: "After any correction, update tasks/lessons.md with the lesson learned. Read lessons.md before starting any task." Your AI gets better every day you use it.</a:t>
+            </a:r>
+          </a:p>
         </p:txBody>
       </p:sp>
       <p:sp>
@@ -7691,6 +7698,13 @@
           <a:p>
             <a:r>
               <a:t>   Now let's see how @ mentions let you feed specific context beyond CLAUDE.md.</a:t>
+            </a:r>
+          </a:p>
+          <a:p>
+            <a:br/>
+            <a:br/>
+            <a:r>
+              <a:t>VERIFICATION BAR: A powerful CLAUDE.md convention from Anthropic's internal team: "Cannot mark a task complete without proving it works. Check diffs, run tests, check logs. The bar: Would a staff engineer approve this?" Add that standard to your CLAUDE.md and Claude holds itself to senior-level quality checks before reporting done.</a:t>
             </a:r>
           </a:p>
         </p:txBody>

</xml_diff>

<commit_message>
docs: add hand-raise opening question to Lab 2A slide speaker notes
</commit_message>
<xml_diff>
--- a/slides/Day2_Claude_Code_Fundamentals.pptx
+++ b/slides/Day2_Claude_Code_Fundamentals.pptx
@@ -8383,6 +8383,13 @@
               <a:t>   Before we dive into installation, let's make sure we're all on the same page about what Claude Code actually is</a:t>
             </a:r>
           </a:p>
+          <a:p>
+            <a:br/>
+            <a:br/>
+            <a:r>
+              <a:t>OPENING QUESTION (before students start the lab): "Raise your hand if you believe AI can generate code." [most hands]. "Keep your hand up if you believe it can debug production failures." [some drop]. "Keep your hand up if you believe it can refactor a large codebase safely." [more drop]. "Good. Today we test all three." Then let them start.</a:t>
+            </a:r>
+          </a:p>
         </p:txBody>
       </p:sp>
       <p:sp>

</xml_diff>

<commit_message>
fix: update all slides to match world-class lab names and descriptions
</commit_message>
<xml_diff>
--- a/slides/Day2_Claude_Code_Fundamentals.pptx
+++ b/slides/Day2_Claude_Code_Fundamentals.pptx
@@ -3291,7 +3291,7 @@
           </a:p>
           <a:p>
             <a:r>
-              <a:t>   Final lab - complete feature workflow.</a:t>
+              <a:t>OPEN WITH: Last lab of the day — you're going to ship this dashboard with production hardening, feature branches, and a scaling review.</a:t>
             </a:r>
           </a:p>
           <a:p>
@@ -25759,7 +25759,7 @@
               </a:defRPr>
             </a:pPr>
             <a:r>
-              <a:t>Lab 2: Real Development Workflow</a:t>
+              <a:t>Lab 2D: Ship It</a:t>
             </a:r>
           </a:p>
         </p:txBody>
@@ -31776,7 +31776,7 @@
               </a:defRPr>
             </a:pPr>
             <a:r>
-              <a:t>Lab 1: Setup &amp; First Project</a:t>
+              <a:t>Lab 2A: The Agentic Build Loop</a:t>
             </a:r>
           </a:p>
         </p:txBody>
@@ -32683,7 +32683,7 @@
               </a:defRPr>
             </a:pPr>
             <a:r>
-              <a:t>Lab 2: Real Development Workflow</a:t>
+              <a:t>Labs 2B-2D: Policy, Recovery, Ship It</a:t>
             </a:r>
           </a:p>
         </p:txBody>
@@ -42176,7 +42176,7 @@
               </a:defRPr>
             </a:pPr>
             <a:r>
-              <a:t>Your Project Brain — CLAUDE.md conventions that enforce themselves</a:t>
+              <a:t>Teaching Claude Your Codebase — policy enforcement, security audit, draft your own</a:t>
             </a:r>
           </a:p>
         </p:txBody>
@@ -42246,7 +42246,7 @@
               </a:defRPr>
             </a:pPr>
             <a:r>
-              <a:t>Precision &amp; Recovery — @ mentions and break-fix workflows</a:t>
+              <a:t>Precision &amp; Recovery — token efficiency, disaster recovery, AI debugging</a:t>
             </a:r>
           </a:p>
         </p:txBody>
@@ -42316,7 +42316,7 @@
               </a:defRPr>
             </a:pPr>
             <a:r>
-              <a:t>Ship It — charts, filters, Git branches, and production hardening</a:t>
+              <a:t>Ship It — production readiness review, feature branches, scaling analysis</a:t>
             </a:r>
           </a:p>
         </p:txBody>
@@ -47482,7 +47482,7 @@
               </a:defRPr>
             </a:pPr>
             <a:r>
-              <a:t>Lab 1: Setup &amp; First Project</a:t>
+              <a:t>Lab 2A: The Agentic Build Loop</a:t>
             </a:r>
           </a:p>
         </p:txBody>

</xml_diff>

<commit_message>
feat: add 'When Claude Code Fails' + 'The Real Skill: Delegation' slides, speaker notes for opening hook/memory/context
</commit_message>
<xml_diff>
--- a/slides/Day2_Claude_Code_Fundamentals.pptx
+++ b/slides/Day2_Claude_Code_Fundamentals.pptx
@@ -62,6 +62,8 @@
     <p:sldId id="307" r:id="rId53"/>
     <p:sldId id="308" r:id="rId54"/>
     <p:sldId id="309" r:id="rId55"/>
+    <p:sldId id="373" r:id="rId126"/>
+    <p:sldId id="374" r:id="rId127"/>
     <p:sldId id="310" r:id="rId56"/>
     <p:sldId id="311" r:id="rId57"/>
     <p:sldId id="312" r:id="rId58"/>
@@ -1346,6 +1348,13 @@
               <a:t>   Let's look at what we're covering today</a:t>
             </a:r>
           </a:p>
+          <a:p>
+            <a:br/>
+            <a:br/>
+            <a:r>
+              <a:t>OPENING HOOK: Before anything else, ask the room: "How long would it take you to build a dashboard with an API, a database, a frontend, input validation, logging, CSV export, and clean git history?" Someone will say a day or two. Then say: "By 4pm today, you'll have done it in about 3 hours — and you'll barely touch the keyboard." Let that land, then move to the agenda.</a:t>
+            </a:r>
+          </a:p>
         </p:txBody>
       </p:sp>
       <p:sp>
@@ -3892,6 +3901,98 @@
 </p:notes>
 </file>
 
+<file path=ppt/notesSlides/notesSlide116.xml><?xml version="1.0" encoding="utf-8"?>
+<p:notes xmlns:a="http://schemas.openxmlformats.org/drawingml/2006/main" xmlns:p="http://schemas.openxmlformats.org/presentationml/2006/main" xmlns:r="http://schemas.openxmlformats.org/officeDocument/2006/relationships">
+  <p:cSld>
+    <p:spTree>
+      <p:nvGrpSpPr>
+        <p:cNvPr id="1" name=""/>
+        <p:cNvGrpSpPr/>
+        <p:nvPr/>
+      </p:nvGrpSpPr>
+      <p:grpSpPr>
+        <a:xfrm>
+          <a:off x="0" y="0"/>
+          <a:ext cx="0" cy="0"/>
+          <a:chOff x="0" y="0"/>
+          <a:chExt cx="0" cy="0"/>
+        </a:xfrm>
+      </p:grpSpPr>
+      <p:sp>
+        <p:nvSpPr>
+          <p:cNvPr id="4" name="Notes Placeholder 3"/>
+          <p:cNvSpPr>
+            <a:spLocks noGrp="1"/>
+          </p:cNvSpPr>
+          <p:nvPr>
+            <p:ph type="body" idx="1"/>
+          </p:nvPr>
+        </p:nvSpPr>
+        <p:spPr/>
+        <p:txBody>
+          <a:bodyPr/>
+          <a:lstStyle/>
+          <a:p>
+            <a:r>
+              <a:t>Before the labs, be honest about limitations. Every fix listed here is a skill they practice in the labs. This slide builds enormous credibility with skeptics.</a:t>
+            </a:r>
+          </a:p>
+        </p:txBody>
+      </p:sp>
+    </p:spTree>
+  </p:cSld>
+  <p:clrMapOvr>
+    <a:masterClrMapping/>
+  </p:clrMapOvr>
+</p:notes>
+</file>
+
+<file path=ppt/notesSlides/notesSlide117.xml><?xml version="1.0" encoding="utf-8"?>
+<p:notes xmlns:a="http://schemas.openxmlformats.org/drawingml/2006/main" xmlns:p="http://schemas.openxmlformats.org/presentationml/2006/main" xmlns:r="http://schemas.openxmlformats.org/officeDocument/2006/relationships">
+  <p:cSld>
+    <p:spTree>
+      <p:nvGrpSpPr>
+        <p:cNvPr id="1" name=""/>
+        <p:cNvGrpSpPr/>
+        <p:nvPr/>
+      </p:nvGrpSpPr>
+      <p:grpSpPr>
+        <a:xfrm>
+          <a:off x="0" y="0"/>
+          <a:ext cx="0" cy="0"/>
+          <a:chOff x="0" y="0"/>
+          <a:chExt cx="0" cy="0"/>
+        </a:xfrm>
+      </p:grpSpPr>
+      <p:sp>
+        <p:nvSpPr>
+          <p:cNvPr id="4" name="Notes Placeholder 3"/>
+          <p:cNvSpPr>
+            <a:spLocks noGrp="1"/>
+          </p:cNvSpPr>
+          <p:nvPr>
+            <p:ph type="body" idx="1"/>
+          </p:nvPr>
+        </p:nvSpPr>
+        <p:spPr/>
+        <p:txBody>
+          <a:bodyPr/>
+          <a:lstStyle/>
+          <a:p>
+            <a:r>
+              <a:t>The skill is delegation — clear intent, right context, let Claude do the work. Same skill that makes great engineering managers. Then launch Lab 2A.</a:t>
+            </a:r>
+          </a:p>
+        </p:txBody>
+      </p:sp>
+    </p:spTree>
+  </p:cSld>
+  <p:clrMapOvr>
+    <a:masterClrMapping/>
+  </p:clrMapOvr>
+</p:notes>
+</file>
+
 <file path=ppt/notesSlides/notesSlide12.xml><?xml version="1.0" encoding="utf-8"?>
 <p:notes xmlns:a="http://schemas.openxmlformats.org/drawingml/2006/main" xmlns:r="http://schemas.openxmlformats.org/officeDocument/2006/relationships" xmlns:p="http://schemas.openxmlformats.org/presentationml/2006/main">
   <p:cSld>
@@ -10293,6 +10394,13 @@
               <a:t>   Now let's optimize your context management with a hands-on demo.</a:t>
             </a:r>
           </a:p>
+          <a:p>
+            <a:br/>
+            <a:br/>
+            <a:r>
+              <a:t>SIMPLIFY THIS FOR THE ROOM: "Context is your budget. You have about 200K tokens. Here's what eats it: conversation history, code files Claude reads, MCP tool descriptions, docs and URLs. Here's how you manage it: /clear resets the conversation, /compact compresses history, .claudeignore excludes files, and @ mentions load only what you need. That's it — four tools to manage your budget." </a:t>
+            </a:r>
+          </a:p>
         </p:txBody>
       </p:sp>
       <p:sp>
@@ -14292,6 +14400,37 @@
           <a:p>
             <a:r>
               <a:t>   With this model in mind, let's get Claude Code installed and see these memory systems in action.</a:t>
+            </a:r>
+          </a:p>
+          <a:p>
+            <a:br/>
+            <a:br/>
+            <a:r>
+              <a:t>ANALOGY TABLE (draw on whiteboard or just speak it):</a:t>
+            </a:r>
+            <a:br/>
+            <a:r>
+              <a:t>Human Brain → Claude Code:</a:t>
+            </a:r>
+            <a:br/>
+            <a:r>
+              <a:t>Working memory → Context window (what Claude is thinking about RIGHT NOW)</a:t>
+            </a:r>
+            <a:br/>
+            <a:r>
+              <a:t>Short-term memory → Session history (this conversation)</a:t>
+            </a:r>
+            <a:br/>
+            <a:r>
+              <a:t>Long-term memory → CLAUDE.md (persists across sessions)</a:t>
+            </a:r>
+            <a:br/>
+            <a:r>
+              <a:t>Muscle memory → Skills &amp; slash commands (automatic behaviors)</a:t>
+            </a:r>
+            <a:br/>
+            <a:r>
+              <a:t>Everything you learn today is about managing these four layers. That's the whole game.</a:t>
             </a:r>
           </a:p>
         </p:txBody>
@@ -28434,6 +28573,567 @@
             </a:pPr>
             <a:r>
               <a:t>- © 2026 AIA Copilot</a:t>
+            </a:r>
+          </a:p>
+        </p:txBody>
+      </p:sp>
+    </p:spTree>
+  </p:cSld>
+  <p:clrMapOvr>
+    <a:masterClrMapping/>
+  </p:clrMapOvr>
+</p:sld>
+</file>
+
+<file path=ppt/slides/slide118.xml><?xml version="1.0" encoding="utf-8"?>
+<p:sld xmlns:a="http://schemas.openxmlformats.org/drawingml/2006/main" xmlns:p="http://schemas.openxmlformats.org/presentationml/2006/main" xmlns:r="http://schemas.openxmlformats.org/officeDocument/2006/relationships">
+  <p:cSld>
+    <p:bg>
+      <p:bgPr>
+        <a:solidFill>
+          <a:srgbClr val="0B0F1A"/>
+        </a:solidFill>
+        <a:effectLst/>
+      </p:bgPr>
+    </p:bg>
+    <p:spTree>
+      <p:nvGrpSpPr>
+        <p:cNvPr id="1" name=""/>
+        <p:cNvGrpSpPr/>
+        <p:nvPr/>
+      </p:nvGrpSpPr>
+      <p:grpSpPr/>
+      <p:sp>
+        <p:nvSpPr>
+          <p:cNvPr id="2" name="TextBox 1"/>
+          <p:cNvSpPr txBox="1"/>
+          <p:nvPr/>
+        </p:nvSpPr>
+        <p:spPr>
+          <a:xfrm>
+            <a:off x="731520" y="548640"/>
+            <a:ext cx="10515600" cy="914400"/>
+          </a:xfrm>
+          <a:prstGeom prst="rect">
+            <a:avLst/>
+          </a:prstGeom>
+          <a:noFill/>
+        </p:spPr>
+        <p:txBody>
+          <a:bodyPr wrap="square">
+            <a:spAutoFit/>
+          </a:bodyPr>
+          <a:lstStyle/>
+          <a:p>
+            <a:pPr>
+              <a:defRPr sz="3600" b="1">
+                <a:solidFill>
+                  <a:srgbClr val="FFFFFF"/>
+                </a:solidFill>
+              </a:defRPr>
+            </a:pPr>
+            <a:r>
+              <a:t>When Claude Code Fails</a:t>
+            </a:r>
+          </a:p>
+        </p:txBody>
+      </p:sp>
+      <p:sp>
+        <p:nvSpPr>
+          <p:cNvPr id="3" name="TextBox 2"/>
+          <p:cNvSpPr txBox="1"/>
+          <p:nvPr/>
+        </p:nvSpPr>
+        <p:spPr>
+          <a:xfrm>
+            <a:off x="731520" y="1371600"/>
+            <a:ext cx="10515600" cy="548640"/>
+          </a:xfrm>
+          <a:prstGeom prst="rect">
+            <a:avLst/>
+          </a:prstGeom>
+          <a:noFill/>
+        </p:spPr>
+        <p:txBody>
+          <a:bodyPr wrap="square">
+            <a:spAutoFit/>
+          </a:bodyPr>
+          <a:lstStyle/>
+          <a:p>
+            <a:pPr>
+              <a:defRPr sz="1800">
+                <a:solidFill>
+                  <a:srgbClr val="00D4AA"/>
+                </a:solidFill>
+              </a:defRPr>
+            </a:pPr>
+            <a:r>
+              <a:t>Honesty builds trust. Here's where it struggles — and how to fix it.</a:t>
+            </a:r>
+          </a:p>
+        </p:txBody>
+      </p:sp>
+      <p:sp>
+        <p:nvSpPr>
+          <p:cNvPr id="4" name="TextBox 3"/>
+          <p:cNvSpPr txBox="1"/>
+          <p:nvPr/>
+        </p:nvSpPr>
+        <p:spPr>
+          <a:xfrm>
+            <a:off x="1097280" y="2194560"/>
+            <a:ext cx="9144000" cy="640080"/>
+          </a:xfrm>
+          <a:prstGeom prst="rect">
+            <a:avLst/>
+          </a:prstGeom>
+          <a:noFill/>
+        </p:spPr>
+        <p:txBody>
+          <a:bodyPr wrap="square">
+            <a:spAutoFit/>
+          </a:bodyPr>
+          <a:lstStyle/>
+          <a:p>
+            <a:r>
+              <a:rPr sz="2000" b="1">
+                <a:solidFill>
+                  <a:srgbClr val="00D4AA"/>
+                </a:solidFill>
+              </a:rPr>
+              <a:t>Ambiguous instructions:  </a:t>
+            </a:r>
+            <a:r>
+              <a:rPr sz="1800">
+                <a:solidFill>
+                  <a:srgbClr val="FFFFFF"/>
+                </a:solidFill>
+              </a:rPr>
+              <a:t>Claude guesses wrong. Fix: be specific.</a:t>
+            </a:r>
+          </a:p>
+        </p:txBody>
+      </p:sp>
+      <p:sp>
+        <p:nvSpPr>
+          <p:cNvPr id="5" name="TextBox 4"/>
+          <p:cNvSpPr txBox="1"/>
+          <p:nvPr/>
+        </p:nvSpPr>
+        <p:spPr>
+          <a:xfrm>
+            <a:off x="1097280" y="2880360"/>
+            <a:ext cx="9144000" cy="640080"/>
+          </a:xfrm>
+          <a:prstGeom prst="rect">
+            <a:avLst/>
+          </a:prstGeom>
+          <a:noFill/>
+        </p:spPr>
+        <p:txBody>
+          <a:bodyPr wrap="square">
+            <a:spAutoFit/>
+          </a:bodyPr>
+          <a:lstStyle/>
+          <a:p>
+            <a:r>
+              <a:rPr sz="2000" b="1">
+                <a:solidFill>
+                  <a:srgbClr val="00D4AA"/>
+                </a:solidFill>
+              </a:rPr>
+              <a:t>Huge codebase, no docs:  </a:t>
+            </a:r>
+            <a:r>
+              <a:rPr sz="1800">
+                <a:solidFill>
+                  <a:srgbClr val="FFFFFF"/>
+                </a:solidFill>
+              </a:rPr>
+              <a:t>Claude drowns in context. Fix: CLAUDE.md + .claudeignore</a:t>
+            </a:r>
+          </a:p>
+        </p:txBody>
+      </p:sp>
+      <p:sp>
+        <p:nvSpPr>
+          <p:cNvPr id="6" name="TextBox 5"/>
+          <p:cNvSpPr txBox="1"/>
+          <p:nvPr/>
+        </p:nvSpPr>
+        <p:spPr>
+          <a:xfrm>
+            <a:off x="1097280" y="3566160"/>
+            <a:ext cx="9144000" cy="640080"/>
+          </a:xfrm>
+          <a:prstGeom prst="rect">
+            <a:avLst/>
+          </a:prstGeom>
+          <a:noFill/>
+        </p:spPr>
+        <p:txBody>
+          <a:bodyPr wrap="square">
+            <a:spAutoFit/>
+          </a:bodyPr>
+          <a:lstStyle/>
+          <a:p>
+            <a:r>
+              <a:rPr sz="2000" b="1">
+                <a:solidFill>
+                  <a:srgbClr val="00D4AA"/>
+                </a:solidFill>
+              </a:rPr>
+              <a:t>Complex state across files:  </a:t>
+            </a:r>
+            <a:r>
+              <a:rPr sz="1800">
+                <a:solidFill>
+                  <a:srgbClr val="FFFFFF"/>
+                </a:solidFill>
+              </a:rPr>
+              <a:t>Claude loses track. Fix: @ mentions to focus.</a:t>
+            </a:r>
+          </a:p>
+        </p:txBody>
+      </p:sp>
+      <p:sp>
+        <p:nvSpPr>
+          <p:cNvPr id="7" name="TextBox 6"/>
+          <p:cNvSpPr txBox="1"/>
+          <p:nvPr/>
+        </p:nvSpPr>
+        <p:spPr>
+          <a:xfrm>
+            <a:off x="1097280" y="4251960"/>
+            <a:ext cx="9144000" cy="640080"/>
+          </a:xfrm>
+          <a:prstGeom prst="rect">
+            <a:avLst/>
+          </a:prstGeom>
+          <a:noFill/>
+        </p:spPr>
+        <p:txBody>
+          <a:bodyPr wrap="square">
+            <a:spAutoFit/>
+          </a:bodyPr>
+          <a:lstStyle/>
+          <a:p>
+            <a:r>
+              <a:rPr sz="2000" b="1">
+                <a:solidFill>
+                  <a:srgbClr val="00D4AA"/>
+                </a:solidFill>
+              </a:rPr>
+              <a:t>Missing dependencies:  </a:t>
+            </a:r>
+            <a:r>
+              <a:rPr sz="1800">
+                <a:solidFill>
+                  <a:srgbClr val="FFFFFF"/>
+                </a:solidFill>
+              </a:rPr>
+              <a:t>Build fails silently. Fix: describe your environment.</a:t>
+            </a:r>
+          </a:p>
+        </p:txBody>
+      </p:sp>
+      <p:sp>
+        <p:nvSpPr>
+          <p:cNvPr id="8" name="TextBox 7"/>
+          <p:cNvSpPr txBox="1"/>
+          <p:nvPr/>
+        </p:nvSpPr>
+        <p:spPr>
+          <a:xfrm>
+            <a:off x="1097280" y="4937760"/>
+            <a:ext cx="9144000" cy="640080"/>
+          </a:xfrm>
+          <a:prstGeom prst="rect">
+            <a:avLst/>
+          </a:prstGeom>
+          <a:noFill/>
+        </p:spPr>
+        <p:txBody>
+          <a:bodyPr wrap="square">
+            <a:spAutoFit/>
+          </a:bodyPr>
+          <a:lstStyle/>
+          <a:p>
+            <a:r>
+              <a:rPr sz="2000" b="1">
+                <a:solidFill>
+                  <a:srgbClr val="00D4AA"/>
+                </a:solidFill>
+              </a:rPr>
+              <a:t>One massive prompt:  </a:t>
+            </a:r>
+            <a:r>
+              <a:rPr sz="1800">
+                <a:solidFill>
+                  <a:srgbClr val="FFFFFF"/>
+                </a:solidFill>
+              </a:rPr>
+              <a:t>Claude tries too much. Fix: break into smaller tasks.</a:t>
+            </a:r>
+          </a:p>
+        </p:txBody>
+      </p:sp>
+    </p:spTree>
+  </p:cSld>
+  <p:clrMapOvr>
+    <a:masterClrMapping/>
+  </p:clrMapOvr>
+</p:sld>
+</file>
+
+<file path=ppt/slides/slide119.xml><?xml version="1.0" encoding="utf-8"?>
+<p:sld xmlns:a="http://schemas.openxmlformats.org/drawingml/2006/main" xmlns:p="http://schemas.openxmlformats.org/presentationml/2006/main" xmlns:r="http://schemas.openxmlformats.org/officeDocument/2006/relationships">
+  <p:cSld>
+    <p:bg>
+      <p:bgPr>
+        <a:solidFill>
+          <a:srgbClr val="0B0F1A"/>
+        </a:solidFill>
+        <a:effectLst/>
+      </p:bgPr>
+    </p:bg>
+    <p:spTree>
+      <p:nvGrpSpPr>
+        <p:cNvPr id="1" name=""/>
+        <p:cNvGrpSpPr/>
+        <p:nvPr/>
+      </p:nvGrpSpPr>
+      <p:grpSpPr/>
+      <p:sp>
+        <p:nvSpPr>
+          <p:cNvPr id="2" name="TextBox 1"/>
+          <p:cNvSpPr txBox="1"/>
+          <p:nvPr/>
+        </p:nvSpPr>
+        <p:spPr>
+          <a:xfrm>
+            <a:off x="731520" y="548640"/>
+            <a:ext cx="10515600" cy="914400"/>
+          </a:xfrm>
+          <a:prstGeom prst="rect">
+            <a:avLst/>
+          </a:prstGeom>
+          <a:noFill/>
+        </p:spPr>
+        <p:txBody>
+          <a:bodyPr wrap="square">
+            <a:spAutoFit/>
+          </a:bodyPr>
+          <a:lstStyle/>
+          <a:p>
+            <a:pPr>
+              <a:defRPr sz="3600" b="1">
+                <a:solidFill>
+                  <a:srgbClr val="FFFFFF"/>
+                </a:solidFill>
+              </a:defRPr>
+            </a:pPr>
+            <a:r>
+              <a:t>The Real Skill: Delegation</a:t>
+            </a:r>
+          </a:p>
+        </p:txBody>
+      </p:sp>
+      <p:sp>
+        <p:nvSpPr>
+          <p:cNvPr id="3" name="TextBox 2"/>
+          <p:cNvSpPr txBox="1"/>
+          <p:nvPr/>
+        </p:nvSpPr>
+        <p:spPr>
+          <a:xfrm>
+            <a:off x="731520" y="1371600"/>
+            <a:ext cx="10515600" cy="548640"/>
+          </a:xfrm>
+          <a:prstGeom prst="rect">
+            <a:avLst/>
+          </a:prstGeom>
+          <a:noFill/>
+        </p:spPr>
+        <p:txBody>
+          <a:bodyPr wrap="square">
+            <a:spAutoFit/>
+          </a:bodyPr>
+          <a:lstStyle/>
+          <a:p>
+            <a:pPr>
+              <a:defRPr sz="1800">
+                <a:solidFill>
+                  <a:srgbClr val="00D4AA"/>
+                </a:solidFill>
+              </a:defRPr>
+            </a:pPr>
+            <a:r>
+              <a:t>You're not learning to prompt. You're learning to manage an AI engineer.</a:t>
+            </a:r>
+          </a:p>
+        </p:txBody>
+      </p:sp>
+      <p:sp>
+        <p:nvSpPr>
+          <p:cNvPr id="4" name="TextBox 3"/>
+          <p:cNvSpPr txBox="1"/>
+          <p:nvPr/>
+        </p:nvSpPr>
+        <p:spPr>
+          <a:xfrm>
+            <a:off x="1097280" y="2194560"/>
+            <a:ext cx="9144000" cy="640080"/>
+          </a:xfrm>
+          <a:prstGeom prst="rect">
+            <a:avLst/>
+          </a:prstGeom>
+          <a:noFill/>
+        </p:spPr>
+        <p:txBody>
+          <a:bodyPr wrap="square">
+            <a:spAutoFit/>
+          </a:bodyPr>
+          <a:lstStyle/>
+          <a:p>
+            <a:r>
+              <a:rPr sz="2000" b="1">
+                <a:solidFill>
+                  <a:srgbClr val="00D4AA"/>
+                </a:solidFill>
+              </a:rPr>
+              <a:t>Bad:  </a:t>
+            </a:r>
+            <a:r>
+              <a:rPr sz="1800">
+                <a:solidFill>
+                  <a:srgbClr val="FFFFFF"/>
+                </a:solidFill>
+              </a:rPr>
+              <a:t>"Write authentication."</a:t>
+            </a:r>
+          </a:p>
+        </p:txBody>
+      </p:sp>
+      <p:sp>
+        <p:nvSpPr>
+          <p:cNvPr id="5" name="TextBox 4"/>
+          <p:cNvSpPr txBox="1"/>
+          <p:nvPr/>
+        </p:nvSpPr>
+        <p:spPr>
+          <a:xfrm>
+            <a:off x="1097280" y="2880360"/>
+            <a:ext cx="9144000" cy="640080"/>
+          </a:xfrm>
+          <a:prstGeom prst="rect">
+            <a:avLst/>
+          </a:prstGeom>
+          <a:noFill/>
+        </p:spPr>
+        <p:txBody>
+          <a:bodyPr wrap="square">
+            <a:spAutoFit/>
+          </a:bodyPr>
+          <a:lstStyle/>
+          <a:p>
+            <a:r>
+              <a:rPr sz="2000" b="1">
+                <a:solidFill>
+                  <a:srgbClr val="00D4AA"/>
+                </a:solidFill>
+              </a:rPr>
+              <a:t>Good:  </a:t>
+            </a:r>
+            <a:r>
+              <a:rPr sz="1800">
+                <a:solidFill>
+                  <a:srgbClr val="FFFFFF"/>
+                </a:solidFill>
+              </a:rPr>
+              <a:t>"Add JWT auth to @auth.js using the middleware pattern in @payments.js"</a:t>
+            </a:r>
+          </a:p>
+        </p:txBody>
+      </p:sp>
+      <p:sp>
+        <p:nvSpPr>
+          <p:cNvPr id="6" name="TextBox 5"/>
+          <p:cNvSpPr txBox="1"/>
+          <p:nvPr/>
+        </p:nvSpPr>
+        <p:spPr>
+          <a:xfrm>
+            <a:off x="1097280" y="3566160"/>
+            <a:ext cx="9144000" cy="640080"/>
+          </a:xfrm>
+          <a:prstGeom prst="rect">
+            <a:avLst/>
+          </a:prstGeom>
+          <a:noFill/>
+        </p:spPr>
+        <p:txBody>
+          <a:bodyPr wrap="square">
+            <a:spAutoFit/>
+          </a:bodyPr>
+          <a:lstStyle/>
+          <a:p>
+            <a:r>
+              <a:rPr sz="2000" b="1">
+                <a:solidFill>
+                  <a:srgbClr val="00D4AA"/>
+                </a:solidFill>
+              </a:rPr>
+              <a:t>Bad:  </a:t>
+            </a:r>
+            <a:r>
+              <a:rPr sz="1800">
+                <a:solidFill>
+                  <a:srgbClr val="FFFFFF"/>
+                </a:solidFill>
+              </a:rPr>
+              <a:t>"Fix the bug."</a:t>
+            </a:r>
+          </a:p>
+        </p:txBody>
+      </p:sp>
+      <p:sp>
+        <p:nvSpPr>
+          <p:cNvPr id="7" name="TextBox 6"/>
+          <p:cNvSpPr txBox="1"/>
+          <p:nvPr/>
+        </p:nvSpPr>
+        <p:spPr>
+          <a:xfrm>
+            <a:off x="1097280" y="4251960"/>
+            <a:ext cx="9144000" cy="640080"/>
+          </a:xfrm>
+          <a:prstGeom prst="rect">
+            <a:avLst/>
+          </a:prstGeom>
+          <a:noFill/>
+        </p:spPr>
+        <p:txBody>
+          <a:bodyPr wrap="square">
+            <a:spAutoFit/>
+          </a:bodyPr>
+          <a:lstStyle/>
+          <a:p>
+            <a:r>
+              <a:rPr sz="2000" b="1">
+                <a:solidFill>
+                  <a:srgbClr val="00D4AA"/>
+                </a:solidFill>
+              </a:rPr>
+              <a:t>Good:  </a:t>
+            </a:r>
+            <a:r>
+              <a:rPr sz="1800">
+                <a:solidFill>
+                  <a:srgbClr val="FFFFFF"/>
+                </a:solidFill>
+              </a:rPr>
+              <a:t>"POST /api/tasks returns 500. Check @src/routes/tasks.js for the error."</a:t>
             </a:r>
           </a:p>
         </p:txBody>

</xml_diff>

<commit_message>
feat: add 'What Happens When You Press Enter' step-flow slide (120 slides)
</commit_message>
<xml_diff>
--- a/slides/Day2_Claude_Code_Fundamentals.pptx
+++ b/slides/Day2_Claude_Code_Fundamentals.pptx
@@ -32,6 +32,7 @@
     <p:sldId id="278" r:id="rId24"/>
     <p:sldId id="279" r:id="rId25"/>
     <p:sldId id="280" r:id="rId26"/>
+    <p:sldId id="375" r:id="rId128"/>
     <p:sldId id="281" r:id="rId27"/>
     <p:sldId id="263" r:id="rId9"/>
     <p:sldId id="282" r:id="rId28"/>
@@ -3935,6 +3936,52 @@
 </p:notes>
 </file>
 
+<file path=ppt/notesSlides/notesSlide118.xml><?xml version="1.0" encoding="utf-8"?>
+<p:notes xmlns:a="http://schemas.openxmlformats.org/drawingml/2006/main" xmlns:p="http://schemas.openxmlformats.org/presentationml/2006/main" xmlns:r="http://schemas.openxmlformats.org/officeDocument/2006/relationships">
+  <p:cSld>
+    <p:spTree>
+      <p:nvGrpSpPr>
+        <p:cNvPr id="1" name=""/>
+        <p:cNvGrpSpPr/>
+        <p:nvPr/>
+      </p:nvGrpSpPr>
+      <p:grpSpPr>
+        <a:xfrm>
+          <a:off x="0" y="0"/>
+          <a:ext cx="0" cy="0"/>
+          <a:chOff x="0" y="0"/>
+          <a:chExt cx="0" cy="0"/>
+        </a:xfrm>
+      </p:grpSpPr>
+      <p:sp>
+        <p:nvSpPr>
+          <p:cNvPr id="4" name="Notes Placeholder 3"/>
+          <p:cNvSpPr>
+            <a:spLocks noGrp="1"/>
+          </p:cNvSpPr>
+          <p:nvPr>
+            <p:ph type="body" idx="1"/>
+          </p:nvPr>
+        </p:nvSpPr>
+        <p:spPr/>
+        <p:txBody>
+          <a:bodyPr/>
+          <a:lstStyle/>
+          <a:p>
+            <a:r>
+              <a:t>Walk through each step. Emphasize: the developer only does step 1 (intent). Claude does everything else. The self-healing loop at the bottom is why this is an agent, not autocomplete. Flag: graphic version of this diagram is planned.</a:t>
+            </a:r>
+          </a:p>
+        </p:txBody>
+      </p:sp>
+    </p:spTree>
+  </p:cSld>
+  <p:clrMapOvr>
+    <a:masterClrMapping/>
+  </p:clrMapOvr>
+</p:notes>
+</file>
+
 <file path=ppt/notesSlides/notesSlide12.xml><?xml version="1.0" encoding="utf-8"?>
 <p:notes xmlns:a="http://schemas.openxmlformats.org/drawingml/2006/main" xmlns:r="http://schemas.openxmlformats.org/officeDocument/2006/relationships" xmlns:p="http://schemas.openxmlformats.org/presentationml/2006/main">
   <p:cSld>
@@ -29607,6 +29654,697 @@
           </a:effectLst>
         </p:spPr>
       </p:pic>
+    </p:spTree>
+  </p:cSld>
+  <p:clrMapOvr>
+    <a:masterClrMapping/>
+  </p:clrMapOvr>
+</p:sld>
+</file>
+
+<file path=ppt/slides/slide120.xml><?xml version="1.0" encoding="utf-8"?>
+<p:sld xmlns:a="http://schemas.openxmlformats.org/drawingml/2006/main" xmlns:p="http://schemas.openxmlformats.org/presentationml/2006/main" xmlns:r="http://schemas.openxmlformats.org/officeDocument/2006/relationships">
+  <p:cSld>
+    <p:bg>
+      <p:bgPr>
+        <a:solidFill>
+          <a:srgbClr val="0B0F1A"/>
+        </a:solidFill>
+        <a:effectLst/>
+      </p:bgPr>
+    </p:bg>
+    <p:spTree>
+      <p:nvGrpSpPr>
+        <p:cNvPr id="1" name=""/>
+        <p:cNvGrpSpPr/>
+        <p:nvPr/>
+      </p:nvGrpSpPr>
+      <p:grpSpPr/>
+      <p:sp>
+        <p:nvSpPr>
+          <p:cNvPr id="2" name="TextBox 1"/>
+          <p:cNvSpPr txBox="1"/>
+          <p:nvPr/>
+        </p:nvSpPr>
+        <p:spPr>
+          <a:xfrm>
+            <a:off x="731520" y="365760"/>
+            <a:ext cx="10515600" cy="731520"/>
+          </a:xfrm>
+          <a:prstGeom prst="rect">
+            <a:avLst/>
+          </a:prstGeom>
+          <a:noFill/>
+        </p:spPr>
+        <p:txBody>
+          <a:bodyPr wrap="square">
+            <a:spAutoFit/>
+          </a:bodyPr>
+          <a:lstStyle/>
+          <a:p>
+            <a:pPr>
+              <a:defRPr sz="3200" b="1">
+                <a:solidFill>
+                  <a:srgbClr val="FFFFFF"/>
+                </a:solidFill>
+              </a:defRPr>
+            </a:pPr>
+            <a:r>
+              <a:t>What Happens When You Press Enter</a:t>
+            </a:r>
+          </a:p>
+        </p:txBody>
+      </p:sp>
+      <p:sp>
+        <p:nvSpPr>
+          <p:cNvPr id="3" name="TextBox 2"/>
+          <p:cNvSpPr txBox="1"/>
+          <p:nvPr/>
+        </p:nvSpPr>
+        <p:spPr>
+          <a:xfrm>
+            <a:off x="731520" y="1005840"/>
+            <a:ext cx="10515600" cy="457200"/>
+          </a:xfrm>
+          <a:prstGeom prst="rect">
+            <a:avLst/>
+          </a:prstGeom>
+          <a:noFill/>
+        </p:spPr>
+        <p:txBody>
+          <a:bodyPr wrap="none">
+            <a:spAutoFit/>
+          </a:bodyPr>
+          <a:lstStyle/>
+          <a:p>
+            <a:pPr>
+              <a:defRPr sz="1600">
+                <a:solidFill>
+                  <a:srgbClr val="8A8F98"/>
+                </a:solidFill>
+              </a:defRPr>
+            </a:pPr>
+            <a:r>
+              <a:t>The complete flow — from your intent to working code</a:t>
+            </a:r>
+          </a:p>
+        </p:txBody>
+      </p:sp>
+      <p:sp>
+        <p:nvSpPr>
+          <p:cNvPr id="4" name="TextBox 3"/>
+          <p:cNvSpPr txBox="1"/>
+          <p:nvPr/>
+        </p:nvSpPr>
+        <p:spPr>
+          <a:xfrm>
+            <a:off x="2286000" y="1645920"/>
+            <a:ext cx="2743200" cy="365760"/>
+          </a:xfrm>
+          <a:prstGeom prst="rect">
+            <a:avLst/>
+          </a:prstGeom>
+          <a:noFill/>
+        </p:spPr>
+        <p:txBody>
+          <a:bodyPr wrap="none">
+            <a:spAutoFit/>
+          </a:bodyPr>
+          <a:lstStyle/>
+          <a:p>
+            <a:pPr algn="l">
+              <a:defRPr sz="2000" b="1">
+                <a:solidFill>
+                  <a:srgbClr val="00D4AA"/>
+                </a:solidFill>
+              </a:defRPr>
+            </a:pPr>
+            <a:r>
+              <a:t>YOUR INTENT</a:t>
+            </a:r>
+          </a:p>
+        </p:txBody>
+      </p:sp>
+      <p:sp>
+        <p:nvSpPr>
+          <p:cNvPr id="5" name="TextBox 4"/>
+          <p:cNvSpPr txBox="1"/>
+          <p:nvPr/>
+        </p:nvSpPr>
+        <p:spPr>
+          <a:xfrm>
+            <a:off x="5303520" y="1645920"/>
+            <a:ext cx="5029200" cy="365760"/>
+          </a:xfrm>
+          <a:prstGeom prst="rect">
+            <a:avLst/>
+          </a:prstGeom>
+          <a:noFill/>
+        </p:spPr>
+        <p:txBody>
+          <a:bodyPr wrap="none">
+            <a:spAutoFit/>
+          </a:bodyPr>
+          <a:lstStyle/>
+          <a:p>
+            <a:pPr>
+              <a:defRPr sz="1600">
+                <a:solidFill>
+                  <a:srgbClr val="FFFFFF"/>
+                </a:solidFill>
+              </a:defRPr>
+            </a:pPr>
+            <a:r>
+              <a:t>You describe what you want</a:t>
+            </a:r>
+          </a:p>
+        </p:txBody>
+      </p:sp>
+      <p:sp>
+        <p:nvSpPr>
+          <p:cNvPr id="6" name="TextBox 5"/>
+          <p:cNvSpPr txBox="1"/>
+          <p:nvPr/>
+        </p:nvSpPr>
+        <p:spPr>
+          <a:xfrm>
+            <a:off x="4114800" y="2057400"/>
+            <a:ext cx="914400" cy="274320"/>
+          </a:xfrm>
+          <a:prstGeom prst="rect">
+            <a:avLst/>
+          </a:prstGeom>
+          <a:noFill/>
+        </p:spPr>
+        <p:txBody>
+          <a:bodyPr wrap="none">
+            <a:spAutoFit/>
+          </a:bodyPr>
+          <a:lstStyle/>
+          <a:p>
+            <a:pPr algn="l">
+              <a:defRPr sz="2000">
+                <a:solidFill>
+                  <a:srgbClr val="00D4AA"/>
+                </a:solidFill>
+              </a:defRPr>
+            </a:pPr>
+            <a:r>
+              <a:t>↓</a:t>
+            </a:r>
+          </a:p>
+        </p:txBody>
+      </p:sp>
+      <p:sp>
+        <p:nvSpPr>
+          <p:cNvPr id="7" name="TextBox 6"/>
+          <p:cNvSpPr txBox="1"/>
+          <p:nvPr/>
+        </p:nvSpPr>
+        <p:spPr>
+          <a:xfrm>
+            <a:off x="2286000" y="2331720"/>
+            <a:ext cx="2743200" cy="365760"/>
+          </a:xfrm>
+          <a:prstGeom prst="rect">
+            <a:avLst/>
+          </a:prstGeom>
+          <a:noFill/>
+        </p:spPr>
+        <p:txBody>
+          <a:bodyPr wrap="none">
+            <a:spAutoFit/>
+          </a:bodyPr>
+          <a:lstStyle/>
+          <a:p>
+            <a:pPr algn="l">
+              <a:defRPr sz="2000" b="1">
+                <a:solidFill>
+                  <a:srgbClr val="00D4AA"/>
+                </a:solidFill>
+              </a:defRPr>
+            </a:pPr>
+            <a:r>
+              <a:t>READ CODEBASE</a:t>
+            </a:r>
+          </a:p>
+        </p:txBody>
+      </p:sp>
+      <p:sp>
+        <p:nvSpPr>
+          <p:cNvPr id="8" name="TextBox 7"/>
+          <p:cNvSpPr txBox="1"/>
+          <p:nvPr/>
+        </p:nvSpPr>
+        <p:spPr>
+          <a:xfrm>
+            <a:off x="5303520" y="2331720"/>
+            <a:ext cx="5029200" cy="365760"/>
+          </a:xfrm>
+          <a:prstGeom prst="rect">
+            <a:avLst/>
+          </a:prstGeom>
+          <a:noFill/>
+        </p:spPr>
+        <p:txBody>
+          <a:bodyPr wrap="none">
+            <a:spAutoFit/>
+          </a:bodyPr>
+          <a:lstStyle/>
+          <a:p>
+            <a:pPr>
+              <a:defRPr sz="1600">
+                <a:solidFill>
+                  <a:srgbClr val="FFFFFF"/>
+                </a:solidFill>
+              </a:defRPr>
+            </a:pPr>
+            <a:r>
+              <a:t>CLAUDE.md + relevant files + git history</a:t>
+            </a:r>
+          </a:p>
+        </p:txBody>
+      </p:sp>
+      <p:sp>
+        <p:nvSpPr>
+          <p:cNvPr id="9" name="TextBox 8"/>
+          <p:cNvSpPr txBox="1"/>
+          <p:nvPr/>
+        </p:nvSpPr>
+        <p:spPr>
+          <a:xfrm>
+            <a:off x="4114800" y="2743200"/>
+            <a:ext cx="914400" cy="274320"/>
+          </a:xfrm>
+          <a:prstGeom prst="rect">
+            <a:avLst/>
+          </a:prstGeom>
+          <a:noFill/>
+        </p:spPr>
+        <p:txBody>
+          <a:bodyPr wrap="none">
+            <a:spAutoFit/>
+          </a:bodyPr>
+          <a:lstStyle/>
+          <a:p>
+            <a:pPr algn="l">
+              <a:defRPr sz="2000">
+                <a:solidFill>
+                  <a:srgbClr val="00D4AA"/>
+                </a:solidFill>
+              </a:defRPr>
+            </a:pPr>
+            <a:r>
+              <a:t>↓</a:t>
+            </a:r>
+          </a:p>
+        </p:txBody>
+      </p:sp>
+      <p:sp>
+        <p:nvSpPr>
+          <p:cNvPr id="10" name="TextBox 9"/>
+          <p:cNvSpPr txBox="1"/>
+          <p:nvPr/>
+        </p:nvSpPr>
+        <p:spPr>
+          <a:xfrm>
+            <a:off x="2286000" y="3017520"/>
+            <a:ext cx="2743200" cy="365760"/>
+          </a:xfrm>
+          <a:prstGeom prst="rect">
+            <a:avLst/>
+          </a:prstGeom>
+          <a:noFill/>
+        </p:spPr>
+        <p:txBody>
+          <a:bodyPr wrap="none">
+            <a:spAutoFit/>
+          </a:bodyPr>
+          <a:lstStyle/>
+          <a:p>
+            <a:pPr algn="l">
+              <a:defRPr sz="2000" b="1">
+                <a:solidFill>
+                  <a:srgbClr val="00D4AA"/>
+                </a:solidFill>
+              </a:defRPr>
+            </a:pPr>
+            <a:r>
+              <a:t>PLAN CHANGES</a:t>
+            </a:r>
+          </a:p>
+        </p:txBody>
+      </p:sp>
+      <p:sp>
+        <p:nvSpPr>
+          <p:cNvPr id="11" name="TextBox 10"/>
+          <p:cNvSpPr txBox="1"/>
+          <p:nvPr/>
+        </p:nvSpPr>
+        <p:spPr>
+          <a:xfrm>
+            <a:off x="5303520" y="3017520"/>
+            <a:ext cx="5029200" cy="365760"/>
+          </a:xfrm>
+          <a:prstGeom prst="rect">
+            <a:avLst/>
+          </a:prstGeom>
+          <a:noFill/>
+        </p:spPr>
+        <p:txBody>
+          <a:bodyPr wrap="none">
+            <a:spAutoFit/>
+          </a:bodyPr>
+          <a:lstStyle/>
+          <a:p>
+            <a:pPr>
+              <a:defRPr sz="1600">
+                <a:solidFill>
+                  <a:srgbClr val="FFFFFF"/>
+                </a:solidFill>
+              </a:defRPr>
+            </a:pPr>
+            <a:r>
+              <a:t>Design approach, choose files to modify</a:t>
+            </a:r>
+          </a:p>
+        </p:txBody>
+      </p:sp>
+      <p:sp>
+        <p:nvSpPr>
+          <p:cNvPr id="12" name="TextBox 11"/>
+          <p:cNvSpPr txBox="1"/>
+          <p:nvPr/>
+        </p:nvSpPr>
+        <p:spPr>
+          <a:xfrm>
+            <a:off x="4114800" y="3429000"/>
+            <a:ext cx="914400" cy="274320"/>
+          </a:xfrm>
+          <a:prstGeom prst="rect">
+            <a:avLst/>
+          </a:prstGeom>
+          <a:noFill/>
+        </p:spPr>
+        <p:txBody>
+          <a:bodyPr wrap="none">
+            <a:spAutoFit/>
+          </a:bodyPr>
+          <a:lstStyle/>
+          <a:p>
+            <a:pPr algn="l">
+              <a:defRPr sz="2000">
+                <a:solidFill>
+                  <a:srgbClr val="00D4AA"/>
+                </a:solidFill>
+              </a:defRPr>
+            </a:pPr>
+            <a:r>
+              <a:t>↓</a:t>
+            </a:r>
+          </a:p>
+        </p:txBody>
+      </p:sp>
+      <p:sp>
+        <p:nvSpPr>
+          <p:cNvPr id="13" name="TextBox 12"/>
+          <p:cNvSpPr txBox="1"/>
+          <p:nvPr/>
+        </p:nvSpPr>
+        <p:spPr>
+          <a:xfrm>
+            <a:off x="2286000" y="3703320"/>
+            <a:ext cx="2743200" cy="365760"/>
+          </a:xfrm>
+          <a:prstGeom prst="rect">
+            <a:avLst/>
+          </a:prstGeom>
+          <a:noFill/>
+        </p:spPr>
+        <p:txBody>
+          <a:bodyPr wrap="none">
+            <a:spAutoFit/>
+          </a:bodyPr>
+          <a:lstStyle/>
+          <a:p>
+            <a:pPr algn="l">
+              <a:defRPr sz="2000" b="1">
+                <a:solidFill>
+                  <a:srgbClr val="00D4AA"/>
+                </a:solidFill>
+              </a:defRPr>
+            </a:pPr>
+            <a:r>
+              <a:t>EDIT FILES</a:t>
+            </a:r>
+          </a:p>
+        </p:txBody>
+      </p:sp>
+      <p:sp>
+        <p:nvSpPr>
+          <p:cNvPr id="14" name="TextBox 13"/>
+          <p:cNvSpPr txBox="1"/>
+          <p:nvPr/>
+        </p:nvSpPr>
+        <p:spPr>
+          <a:xfrm>
+            <a:off x="5303520" y="3703320"/>
+            <a:ext cx="5029200" cy="365760"/>
+          </a:xfrm>
+          <a:prstGeom prst="rect">
+            <a:avLst/>
+          </a:prstGeom>
+          <a:noFill/>
+        </p:spPr>
+        <p:txBody>
+          <a:bodyPr wrap="none">
+            <a:spAutoFit/>
+          </a:bodyPr>
+          <a:lstStyle/>
+          <a:p>
+            <a:pPr>
+              <a:defRPr sz="1600">
+                <a:solidFill>
+                  <a:srgbClr val="FFFFFF"/>
+                </a:solidFill>
+              </a:defRPr>
+            </a:pPr>
+            <a:r>
+              <a:t>Write code, create files, update imports</a:t>
+            </a:r>
+          </a:p>
+        </p:txBody>
+      </p:sp>
+      <p:sp>
+        <p:nvSpPr>
+          <p:cNvPr id="15" name="TextBox 14"/>
+          <p:cNvSpPr txBox="1"/>
+          <p:nvPr/>
+        </p:nvSpPr>
+        <p:spPr>
+          <a:xfrm>
+            <a:off x="4114800" y="4114800"/>
+            <a:ext cx="914400" cy="274320"/>
+          </a:xfrm>
+          <a:prstGeom prst="rect">
+            <a:avLst/>
+          </a:prstGeom>
+          <a:noFill/>
+        </p:spPr>
+        <p:txBody>
+          <a:bodyPr wrap="none">
+            <a:spAutoFit/>
+          </a:bodyPr>
+          <a:lstStyle/>
+          <a:p>
+            <a:pPr algn="l">
+              <a:defRPr sz="2000">
+                <a:solidFill>
+                  <a:srgbClr val="00D4AA"/>
+                </a:solidFill>
+              </a:defRPr>
+            </a:pPr>
+            <a:r>
+              <a:t>↓</a:t>
+            </a:r>
+          </a:p>
+        </p:txBody>
+      </p:sp>
+      <p:sp>
+        <p:nvSpPr>
+          <p:cNvPr id="16" name="TextBox 15"/>
+          <p:cNvSpPr txBox="1"/>
+          <p:nvPr/>
+        </p:nvSpPr>
+        <p:spPr>
+          <a:xfrm>
+            <a:off x="2286000" y="4389120"/>
+            <a:ext cx="2743200" cy="365760"/>
+          </a:xfrm>
+          <a:prstGeom prst="rect">
+            <a:avLst/>
+          </a:prstGeom>
+          <a:noFill/>
+        </p:spPr>
+        <p:txBody>
+          <a:bodyPr wrap="none">
+            <a:spAutoFit/>
+          </a:bodyPr>
+          <a:lstStyle/>
+          <a:p>
+            <a:pPr algn="l">
+              <a:defRPr sz="2000" b="1">
+                <a:solidFill>
+                  <a:srgbClr val="00D4AA"/>
+                </a:solidFill>
+              </a:defRPr>
+            </a:pPr>
+            <a:r>
+              <a:t>RUN &amp; TEST</a:t>
+            </a:r>
+          </a:p>
+        </p:txBody>
+      </p:sp>
+      <p:sp>
+        <p:nvSpPr>
+          <p:cNvPr id="17" name="TextBox 16"/>
+          <p:cNvSpPr txBox="1"/>
+          <p:nvPr/>
+        </p:nvSpPr>
+        <p:spPr>
+          <a:xfrm>
+            <a:off x="5303520" y="4389120"/>
+            <a:ext cx="5029200" cy="365760"/>
+          </a:xfrm>
+          <a:prstGeom prst="rect">
+            <a:avLst/>
+          </a:prstGeom>
+          <a:noFill/>
+        </p:spPr>
+        <p:txBody>
+          <a:bodyPr wrap="none">
+            <a:spAutoFit/>
+          </a:bodyPr>
+          <a:lstStyle/>
+          <a:p>
+            <a:pPr>
+              <a:defRPr sz="1600">
+                <a:solidFill>
+                  <a:srgbClr val="FFFFFF"/>
+                </a:solidFill>
+              </a:defRPr>
+            </a:pPr>
+            <a:r>
+              <a:t>Execute commands, check output</a:t>
+            </a:r>
+          </a:p>
+        </p:txBody>
+      </p:sp>
+      <p:sp>
+        <p:nvSpPr>
+          <p:cNvPr id="18" name="TextBox 17"/>
+          <p:cNvSpPr txBox="1"/>
+          <p:nvPr/>
+        </p:nvSpPr>
+        <p:spPr>
+          <a:xfrm>
+            <a:off x="4114800" y="4800600"/>
+            <a:ext cx="914400" cy="274320"/>
+          </a:xfrm>
+          <a:prstGeom prst="rect">
+            <a:avLst/>
+          </a:prstGeom>
+          <a:noFill/>
+        </p:spPr>
+        <p:txBody>
+          <a:bodyPr wrap="none">
+            <a:spAutoFit/>
+          </a:bodyPr>
+          <a:lstStyle/>
+          <a:p>
+            <a:pPr algn="l">
+              <a:defRPr sz="2000">
+                <a:solidFill>
+                  <a:srgbClr val="00D4AA"/>
+                </a:solidFill>
+              </a:defRPr>
+            </a:pPr>
+            <a:r>
+              <a:t>↓</a:t>
+            </a:r>
+          </a:p>
+        </p:txBody>
+      </p:sp>
+      <p:sp>
+        <p:nvSpPr>
+          <p:cNvPr id="19" name="TextBox 18"/>
+          <p:cNvSpPr txBox="1"/>
+          <p:nvPr/>
+        </p:nvSpPr>
+        <p:spPr>
+          <a:xfrm>
+            <a:off x="2286000" y="5074920"/>
+            <a:ext cx="2743200" cy="365760"/>
+          </a:xfrm>
+          <a:prstGeom prst="rect">
+            <a:avLst/>
+          </a:prstGeom>
+          <a:noFill/>
+        </p:spPr>
+        <p:txBody>
+          <a:bodyPr wrap="none">
+            <a:spAutoFit/>
+          </a:bodyPr>
+          <a:lstStyle/>
+          <a:p>
+            <a:pPr algn="l">
+              <a:defRPr sz="2000" b="1">
+                <a:solidFill>
+                  <a:srgbClr val="00D4AA"/>
+                </a:solidFill>
+              </a:defRPr>
+            </a:pPr>
+            <a:r>
+              <a:t>FIX FAILURES</a:t>
+            </a:r>
+          </a:p>
+        </p:txBody>
+      </p:sp>
+      <p:sp>
+        <p:nvSpPr>
+          <p:cNvPr id="20" name="TextBox 19"/>
+          <p:cNvSpPr txBox="1"/>
+          <p:nvPr/>
+        </p:nvSpPr>
+        <p:spPr>
+          <a:xfrm>
+            <a:off x="5303520" y="5074920"/>
+            <a:ext cx="5029200" cy="365760"/>
+          </a:xfrm>
+          <a:prstGeom prst="rect">
+            <a:avLst/>
+          </a:prstGeom>
+          <a:noFill/>
+        </p:spPr>
+        <p:txBody>
+          <a:bodyPr wrap="none">
+            <a:spAutoFit/>
+          </a:bodyPr>
+          <a:lstStyle/>
+          <a:p>
+            <a:pPr>
+              <a:defRPr sz="1600">
+                <a:solidFill>
+                  <a:srgbClr val="FFFFFF"/>
+                </a:solidFill>
+              </a:defRPr>
+            </a:pPr>
+            <a:r>
+              <a:t>Read errors, diagnose, retry → self-healing loop</a:t>
+            </a:r>
+          </a:p>
+        </p:txBody>
+      </p:sp>
     </p:spTree>
   </p:cSld>
   <p:clrMapOvr>

</xml_diff>

<commit_message>
fix: slide 3 speaker notes — match 6 objectives, not 9
</commit_message>
<xml_diff>
--- a/slides/Day2_Claude_Code_Fundamentals.pptx
+++ b/slides/Day2_Claude_Code_Fundamentals.pptx
@@ -6878,92 +6878,97 @@
             <a:r>
               <a:t>TIME: 3 min</a:t>
             </a:r>
-          </a:p>
-          <a:p>
-            <a:endParaRPr/>
-          </a:p>
-          <a:p>
+            <a:br/>
+            <a:br/>
             <a:r>
               <a:t>OPEN WITH:</a:t>
             </a:r>
-          </a:p>
-          <a:p>
-            <a:r>
-              <a:t>   Nine objectives today. This might look intimidating, but they build on each other logically. By lunch you'll have five of these checked off.</a:t>
-            </a:r>
-          </a:p>
-          <a:p>
-            <a:endParaRPr/>
-          </a:p>
-          <a:p>
+            <a:br/>
+            <a:r>
+              <a:t>  Six objectives today. They build on each other logically. By lunch you'll have the first four checked off.</a:t>
+            </a:r>
+            <a:br/>
+            <a:br/>
             <a:r>
               <a:t>KEY POINTS:</a:t>
             </a:r>
-          </a:p>
-          <a:p>
-            <a:r>
-              <a:t>   * Objectives one through four are morning content - installation, the core mental model, configuration, and context control</a:t>
-            </a:r>
-          </a:p>
-          <a:p>
-            <a:r>
-              <a:t>   * Objectives five through seven are power user territory - optimization, commands, and security</a:t>
-            </a:r>
-          </a:p>
-          <a:p>
-            <a:r>
-              <a:t>   * The last two objectives are about real workflows - this is where it clicks and becomes part of your daily toolkit</a:t>
-            </a:r>
-          </a:p>
-          <a:p>
-            <a:r>
-              <a:t>   * Every single one of these objectives will be practiced in the labs, not just lectured about</a:t>
-            </a:r>
-          </a:p>
-          <a:p>
-            <a:endParaRPr/>
-          </a:p>
-          <a:p>
+            <a:br/>
+            <a:r>
+              <a:t>  * Objectives 1-2 are the foundation — install the tool, understand the agentic loop</a:t>
+            </a:r>
+            <a:br/>
+            <a:r>
+              <a:t>  * Objectives 3-4 are about control — CLAUDE.md policy and @ mentions for precision</a:t>
+            </a:r>
+            <a:br/>
+            <a:r>
+              <a:t>  * Objectives 5-6 are power user skills — context optimization and slash commands</a:t>
+            </a:r>
+            <a:br/>
+            <a:r>
+              <a:t>  * Every single one of these objectives will be practiced in the labs, not just lectured about</a:t>
+            </a:r>
+            <a:br/>
+            <a:br/>
             <a:r>
               <a:t>ASK THE CLASS:</a:t>
             </a:r>
-          </a:p>
-          <a:p>
-            <a:r>
-              <a:t>   "Quick show of hands - how many of you have used GitHub Copilot or similar autocomplete tools? Keep those hands up if you think Claude Code will be similar. Okay, let's challenge that assumption today."</a:t>
-            </a:r>
-          </a:p>
-          <a:p>
-            <a:r>
-              <a:t>   [PAUSE for 30-60 seconds]</a:t>
-            </a:r>
-          </a:p>
-          <a:p>
-            <a:endParaRPr/>
-          </a:p>
-          <a:p>
+            <a:br/>
+            <a:r>
+              <a:t>  "Quick show of hands — how many of you have used GitHub Copilot or similar autocomplete tools? Keep those hands up if you think Claude Code will be similar. Okay, let's challenge that assumption today."</a:t>
+            </a:r>
+            <a:br/>
+            <a:r>
+              <a:t>  [PAUSE for 30-60 seconds]</a:t>
+            </a:r>
+            <a:br/>
+            <a:br/>
             <a:r>
               <a:t>REAL-WORLD EXAMPLE:</a:t>
             </a:r>
-          </a:p>
-          <a:p>
-            <a:r>
-              <a:t>   A frontend developer in our last cohort had never touched the backend codebase. After this training, she used Claude Code to add three new API endpoints with full test coverage. The backend team approved her PR with zero change requests.</a:t>
-            </a:r>
-          </a:p>
-          <a:p>
-            <a:endParaRPr/>
-          </a:p>
-          <a:p>
+            <a:br/>
+            <a:r>
+              <a:t>  A frontend developer in our last cohort had never touched the backend codebase. After this training, she used Claude Code to add three new API endpoints with full test coverage. The backend team approved her PR with zero change requests.</a:t>
+            </a:r>
+            <a:br/>
+            <a:br/>
             <a:r>
               <a:t>TRANSITION:</a:t>
             </a:r>
-          </a:p>
-          <a:p>
-            <a:r>
-              <a:t>   Here's what you'll actually build today</a:t>
-            </a:r>
-          </a:p>
+            <a:br/>
+            <a:r>
+              <a:t>  Here's what you'll actually build today</a:t>
+            </a:r>
+          </a:p>
+          <a:p>
+            <a:endParaRPr/>
+          </a:p>
+          <a:p/>
+          <a:p/>
+          <a:p>
+            <a:endParaRPr/>
+          </a:p>
+          <a:p/>
+          <a:p/>
+          <a:p/>
+          <a:p/>
+          <a:p/>
+          <a:p>
+            <a:endParaRPr/>
+          </a:p>
+          <a:p/>
+          <a:p/>
+          <a:p/>
+          <a:p>
+            <a:endParaRPr/>
+          </a:p>
+          <a:p/>
+          <a:p/>
+          <a:p>
+            <a:endParaRPr/>
+          </a:p>
+          <a:p/>
+          <a:p/>
         </p:txBody>
       </p:sp>
       <p:sp>

</xml_diff>

<commit_message>
fix: slide 3 notes — 3 objectives by lunch, not 4
</commit_message>
<xml_diff>
--- a/slides/Day2_Claude_Code_Fundamentals.pptx
+++ b/slides/Day2_Claude_Code_Fundamentals.pptx
@@ -6885,7 +6885,7 @@
             </a:r>
             <a:br/>
             <a:r>
-              <a:t>  Six objectives today. They build on each other logically. By lunch you'll have the first four checked off.</a:t>
+              <a:t>  Six objectives today. They build on each other — by lunch you'll have the first three down, and you'll have built a working app and written your own AI policy file.</a:t>
             </a:r>
             <a:br/>
             <a:br/>
@@ -6894,41 +6894,23 @@
             </a:r>
             <a:br/>
             <a:r>
-              <a:t>  * Objectives 1-2 are the foundation — install the tool, understand the agentic loop</a:t>
+              <a:t>  * Objectives 1-2 are the foundation — install the tool, understand the agentic loop (morning + Lab 2A)</a:t>
             </a:r>
             <a:br/>
             <a:r>
-              <a:t>  * Objectives 3-4 are about control — CLAUDE.md policy and @ mentions for precision</a:t>
+              <a:t>  * Objective 3 is about control — CLAUDE.md as project policy (morning + Lab 2B)</a:t>
             </a:r>
             <a:br/>
             <a:r>
-              <a:t>  * Objectives 5-6 are power user skills — context optimization and slash commands</a:t>
+              <a:t>  * Objectives 4-5 are precision skills — @ mentions and context optimization (afternoon + Lab 2C)</a:t>
             </a:r>
             <a:br/>
             <a:r>
-              <a:t>  * Every single one of these objectives will be practiced in the labs, not just lectured about</a:t>
+              <a:t>  * Objective 6 ties it together — commands, Git, shipping (afternoon + Lab 2D)</a:t>
             </a:r>
             <a:br/>
-            <a:br/>
-            <a:r>
-              <a:t>ASK THE CLASS:</a:t>
-            </a:r>
-            <a:br/>
-            <a:r>
-              <a:t>  "Quick show of hands — how many of you have used GitHub Copilot or similar autocomplete tools? Keep those hands up if you think Claude Code will be similar. Okay, let's challenge that assumption today."</a:t>
-            </a:r>
-            <a:br/>
-            <a:r>
-              <a:t>  [PAUSE for 30-60 seconds]</a:t>
-            </a:r>
-            <a:br/>
-            <a:br/>
-            <a:r>
-              <a:t>REAL-WORLD EXAMPLE:</a:t>
-            </a:r>
-            <a:br/>
-            <a:r>
-              <a:t>  A frontend developer in our last cohort had never touched the backend codebase. After this training, she used Claude Code to add three new API endpoints with full test coverage. The backend team approved her PR with zero change requests.</a:t>
+            <a:r>
+              <a:t>  * Every objective is practiced hands-on in the labs</a:t>
             </a:r>
             <a:br/>
             <a:br/>

</xml_diff>